<commit_message>
updated the logical model, and finished seeding the database.
</commit_message>
<xml_diff>
--- a/IS_6420_DatabaseTheory/assignments/logicalModel_YoutubeMusic.pptx
+++ b/IS_6420_DatabaseTheory/assignments/logicalModel_YoutubeMusic.pptx
@@ -107,6 +107,11 @@
       </a:defRPr>
     </a:lvl9pPr>
   </p:defaultTextStyle>
+  <p:extLst>
+    <p:ext uri="{EFAFB233-063F-42B5-8137-9DF3F51BA10A}">
+      <p15:sldGuideLst xmlns:p15="http://schemas.microsoft.com/office/powerpoint/2012/main"/>
+    </p:ext>
+  </p:extLst>
 </p:presentation>
 </file>
 
@@ -257,7 +262,7 @@
           <a:p>
             <a:fld id="{11167275-A416-0B42-B668-03B1EBCF039A}" type="datetimeFigureOut">
               <a:rPr lang="en-US" smtClean="0"/>
-              <a:t>3/3/26</a:t>
+              <a:t>3/5/26</a:t>
             </a:fld>
             <a:endParaRPr lang="en-US"/>
           </a:p>
@@ -455,7 +460,7 @@
           <a:p>
             <a:fld id="{11167275-A416-0B42-B668-03B1EBCF039A}" type="datetimeFigureOut">
               <a:rPr lang="en-US" smtClean="0"/>
-              <a:t>3/3/26</a:t>
+              <a:t>3/5/26</a:t>
             </a:fld>
             <a:endParaRPr lang="en-US"/>
           </a:p>
@@ -663,7 +668,7 @@
           <a:p>
             <a:fld id="{11167275-A416-0B42-B668-03B1EBCF039A}" type="datetimeFigureOut">
               <a:rPr lang="en-US" smtClean="0"/>
-              <a:t>3/3/26</a:t>
+              <a:t>3/5/26</a:t>
             </a:fld>
             <a:endParaRPr lang="en-US"/>
           </a:p>
@@ -861,7 +866,7 @@
           <a:p>
             <a:fld id="{11167275-A416-0B42-B668-03B1EBCF039A}" type="datetimeFigureOut">
               <a:rPr lang="en-US" smtClean="0"/>
-              <a:t>3/3/26</a:t>
+              <a:t>3/5/26</a:t>
             </a:fld>
             <a:endParaRPr lang="en-US"/>
           </a:p>
@@ -1136,7 +1141,7 @@
           <a:p>
             <a:fld id="{11167275-A416-0B42-B668-03B1EBCF039A}" type="datetimeFigureOut">
               <a:rPr lang="en-US" smtClean="0"/>
-              <a:t>3/3/26</a:t>
+              <a:t>3/5/26</a:t>
             </a:fld>
             <a:endParaRPr lang="en-US"/>
           </a:p>
@@ -1401,7 +1406,7 @@
           <a:p>
             <a:fld id="{11167275-A416-0B42-B668-03B1EBCF039A}" type="datetimeFigureOut">
               <a:rPr lang="en-US" smtClean="0"/>
-              <a:t>3/3/26</a:t>
+              <a:t>3/5/26</a:t>
             </a:fld>
             <a:endParaRPr lang="en-US"/>
           </a:p>
@@ -1813,7 +1818,7 @@
           <a:p>
             <a:fld id="{11167275-A416-0B42-B668-03B1EBCF039A}" type="datetimeFigureOut">
               <a:rPr lang="en-US" smtClean="0"/>
-              <a:t>3/3/26</a:t>
+              <a:t>3/5/26</a:t>
             </a:fld>
             <a:endParaRPr lang="en-US"/>
           </a:p>
@@ -1954,7 +1959,7 @@
           <a:p>
             <a:fld id="{11167275-A416-0B42-B668-03B1EBCF039A}" type="datetimeFigureOut">
               <a:rPr lang="en-US" smtClean="0"/>
-              <a:t>3/3/26</a:t>
+              <a:t>3/5/26</a:t>
             </a:fld>
             <a:endParaRPr lang="en-US"/>
           </a:p>
@@ -2067,7 +2072,7 @@
           <a:p>
             <a:fld id="{11167275-A416-0B42-B668-03B1EBCF039A}" type="datetimeFigureOut">
               <a:rPr lang="en-US" smtClean="0"/>
-              <a:t>3/3/26</a:t>
+              <a:t>3/5/26</a:t>
             </a:fld>
             <a:endParaRPr lang="en-US"/>
           </a:p>
@@ -2378,7 +2383,7 @@
           <a:p>
             <a:fld id="{11167275-A416-0B42-B668-03B1EBCF039A}" type="datetimeFigureOut">
               <a:rPr lang="en-US" smtClean="0"/>
-              <a:t>3/3/26</a:t>
+              <a:t>3/5/26</a:t>
             </a:fld>
             <a:endParaRPr lang="en-US"/>
           </a:p>
@@ -2666,7 +2671,7 @@
           <a:p>
             <a:fld id="{11167275-A416-0B42-B668-03B1EBCF039A}" type="datetimeFigureOut">
               <a:rPr lang="en-US" smtClean="0"/>
-              <a:t>3/3/26</a:t>
+              <a:t>3/5/26</a:t>
             </a:fld>
             <a:endParaRPr lang="en-US"/>
           </a:p>
@@ -2907,7 +2912,7 @@
           <a:p>
             <a:fld id="{11167275-A416-0B42-B668-03B1EBCF039A}" type="datetimeFigureOut">
               <a:rPr lang="en-US" smtClean="0"/>
-              <a:t>3/3/26</a:t>
+              <a:t>3/5/26</a:t>
             </a:fld>
             <a:endParaRPr lang="en-US"/>
           </a:p>
@@ -3712,10 +3717,10 @@
       </p:sp>
       <p:sp>
         <p:nvSpPr>
-          <p:cNvPr id="12" name="Rectangle 11">
-            <a:extLst>
-              <a:ext uri="{FF2B5EF4-FFF2-40B4-BE49-F238E27FC236}">
-                <a16:creationId xmlns:a16="http://schemas.microsoft.com/office/drawing/2014/main" id="{2F9799F2-DC32-027B-A5B5-B8F8AD3D94F0}"/>
+          <p:cNvPr id="14" name="Rectangle 13">
+            <a:extLst>
+              <a:ext uri="{FF2B5EF4-FFF2-40B4-BE49-F238E27FC236}">
+                <a16:creationId xmlns:a16="http://schemas.microsoft.com/office/drawing/2014/main" id="{15C212C0-2300-216B-F570-6DAFA85BCA9C}"/>
               </a:ext>
             </a:extLst>
           </p:cNvPr>
@@ -3724,7 +3729,7 @@
         </p:nvSpPr>
         <p:spPr>
           <a:xfrm>
-            <a:off x="172995" y="4226007"/>
+            <a:off x="172995" y="5375184"/>
             <a:ext cx="11837773" cy="1050324"/>
           </a:xfrm>
           <a:prstGeom prst="rect">
@@ -3764,10 +3769,10 @@
       </p:sp>
       <p:sp>
         <p:nvSpPr>
-          <p:cNvPr id="13" name="TextBox 12">
-            <a:extLst>
-              <a:ext uri="{FF2B5EF4-FFF2-40B4-BE49-F238E27FC236}">
-                <a16:creationId xmlns:a16="http://schemas.microsoft.com/office/drawing/2014/main" id="{B6357CB7-C7E5-1509-F92C-8189B39FDD3D}"/>
+          <p:cNvPr id="15" name="TextBox 14">
+            <a:extLst>
+              <a:ext uri="{FF2B5EF4-FFF2-40B4-BE49-F238E27FC236}">
+                <a16:creationId xmlns:a16="http://schemas.microsoft.com/office/drawing/2014/main" id="{9C3EA420-178F-EF16-C17B-47698FEE67A7}"/>
               </a:ext>
             </a:extLst>
           </p:cNvPr>
@@ -3776,7 +3781,7 @@
         </p:nvSpPr>
         <p:spPr>
           <a:xfrm>
-            <a:off x="284205" y="4312503"/>
+            <a:off x="284205" y="5449323"/>
             <a:ext cx="2038865" cy="369332"/>
           </a:xfrm>
           <a:prstGeom prst="rect">
@@ -3791,19 +3796,18 @@
           <a:lstStyle/>
           <a:p>
             <a:r>
-              <a:rPr lang="en-US" dirty="0" err="1"/>
-              <a:t>PlaybackSession</a:t>
-            </a:r>
-            <a:endParaRPr lang="en-US" dirty="0"/>
-          </a:p>
-        </p:txBody>
-      </p:sp>
-      <p:sp>
-        <p:nvSpPr>
-          <p:cNvPr id="14" name="Rectangle 13">
-            <a:extLst>
-              <a:ext uri="{FF2B5EF4-FFF2-40B4-BE49-F238E27FC236}">
-                <a16:creationId xmlns:a16="http://schemas.microsoft.com/office/drawing/2014/main" id="{15C212C0-2300-216B-F570-6DAFA85BCA9C}"/>
+              <a:rPr lang="en-US" dirty="0"/>
+              <a:t>Advertiser</a:t>
+            </a:r>
+          </a:p>
+        </p:txBody>
+      </p:sp>
+      <p:sp>
+        <p:nvSpPr>
+          <p:cNvPr id="18" name="Rectangle 17">
+            <a:extLst>
+              <a:ext uri="{FF2B5EF4-FFF2-40B4-BE49-F238E27FC236}">
+                <a16:creationId xmlns:a16="http://schemas.microsoft.com/office/drawing/2014/main" id="{D749935E-13B2-DFCB-2761-65D176F9B912}"/>
               </a:ext>
             </a:extLst>
           </p:cNvPr>
@@ -3812,17 +3816,14 @@
         </p:nvSpPr>
         <p:spPr>
           <a:xfrm>
-            <a:off x="172995" y="5375184"/>
-            <a:ext cx="11837773" cy="1050324"/>
+            <a:off x="284205" y="1215083"/>
+            <a:ext cx="1830860" cy="520355"/>
           </a:xfrm>
           <a:prstGeom prst="rect">
             <a:avLst/>
           </a:prstGeom>
           <a:solidFill>
-            <a:schemeClr val="accent1">
-              <a:lumMod val="40000"/>
-              <a:lumOff val="60000"/>
-            </a:schemeClr>
+            <a:schemeClr val="bg1"/>
           </a:solidFill>
         </p:spPr>
         <p:style>
@@ -3846,51 +3847,28 @@
           <a:lstStyle/>
           <a:p>
             <a:pPr algn="ctr"/>
-            <a:endParaRPr lang="en-US"/>
-          </a:p>
-        </p:txBody>
-      </p:sp>
-      <p:sp>
-        <p:nvSpPr>
-          <p:cNvPr id="15" name="TextBox 14">
-            <a:extLst>
-              <a:ext uri="{FF2B5EF4-FFF2-40B4-BE49-F238E27FC236}">
-                <a16:creationId xmlns:a16="http://schemas.microsoft.com/office/drawing/2014/main" id="{9C3EA420-178F-EF16-C17B-47698FEE67A7}"/>
-              </a:ext>
-            </a:extLst>
-          </p:cNvPr>
-          <p:cNvSpPr txBox="1"/>
-          <p:nvPr/>
-        </p:nvSpPr>
-        <p:spPr>
-          <a:xfrm>
-            <a:off x="284205" y="5449323"/>
-            <a:ext cx="2038865" cy="369332"/>
-          </a:xfrm>
-          <a:prstGeom prst="rect">
-            <a:avLst/>
-          </a:prstGeom>
-          <a:noFill/>
-        </p:spPr>
-        <p:txBody>
-          <a:bodyPr wrap="square" rtlCol="0">
-            <a:spAutoFit/>
-          </a:bodyPr>
-          <a:lstStyle/>
-          <a:p>
-            <a:r>
-              <a:rPr lang="en-US" dirty="0"/>
-              <a:t>Advertiser</a:t>
-            </a:r>
-          </a:p>
-        </p:txBody>
-      </p:sp>
-      <p:sp>
-        <p:nvSpPr>
-          <p:cNvPr id="18" name="Rectangle 17">
-            <a:extLst>
-              <a:ext uri="{FF2B5EF4-FFF2-40B4-BE49-F238E27FC236}">
-                <a16:creationId xmlns:a16="http://schemas.microsoft.com/office/drawing/2014/main" id="{D749935E-13B2-DFCB-2761-65D176F9B912}"/>
+            <a:r>
+              <a:rPr lang="en-US" u="sng" dirty="0" err="1">
+                <a:solidFill>
+                  <a:sysClr val="windowText" lastClr="000000"/>
+                </a:solidFill>
+              </a:rPr>
+              <a:t>UserID</a:t>
+            </a:r>
+            <a:endParaRPr lang="en-US" u="sng" dirty="0">
+              <a:solidFill>
+                <a:sysClr val="windowText" lastClr="000000"/>
+              </a:solidFill>
+            </a:endParaRPr>
+          </a:p>
+        </p:txBody>
+      </p:sp>
+      <p:sp>
+        <p:nvSpPr>
+          <p:cNvPr id="19" name="Rectangle 18">
+            <a:extLst>
+              <a:ext uri="{FF2B5EF4-FFF2-40B4-BE49-F238E27FC236}">
+                <a16:creationId xmlns:a16="http://schemas.microsoft.com/office/drawing/2014/main" id="{909CDD5A-5555-0AEE-17A0-A45B41095752}"/>
               </a:ext>
             </a:extLst>
           </p:cNvPr>
@@ -3899,7 +3877,7 @@
         </p:nvSpPr>
         <p:spPr>
           <a:xfrm>
-            <a:off x="284205" y="1215083"/>
+            <a:off x="2115065" y="1206845"/>
             <a:ext cx="1830860" cy="520355"/>
           </a:xfrm>
           <a:prstGeom prst="rect">
@@ -3931,27 +3909,22 @@
           <a:p>
             <a:pPr algn="ctr"/>
             <a:r>
-              <a:rPr lang="en-US" u="sng" dirty="0" err="1">
+              <a:rPr lang="en-US" dirty="0">
                 <a:solidFill>
                   <a:sysClr val="windowText" lastClr="000000"/>
                 </a:solidFill>
               </a:rPr>
-              <a:t>UserID</a:t>
-            </a:r>
-            <a:endParaRPr lang="en-US" u="sng" dirty="0">
-              <a:solidFill>
-                <a:sysClr val="windowText" lastClr="000000"/>
-              </a:solidFill>
-            </a:endParaRPr>
-          </a:p>
-        </p:txBody>
-      </p:sp>
-      <p:sp>
-        <p:nvSpPr>
-          <p:cNvPr id="19" name="Rectangle 18">
-            <a:extLst>
-              <a:ext uri="{FF2B5EF4-FFF2-40B4-BE49-F238E27FC236}">
-                <a16:creationId xmlns:a16="http://schemas.microsoft.com/office/drawing/2014/main" id="{909CDD5A-5555-0AEE-17A0-A45B41095752}"/>
+              <a:t>Email</a:t>
+            </a:r>
+          </a:p>
+        </p:txBody>
+      </p:sp>
+      <p:sp>
+        <p:nvSpPr>
+          <p:cNvPr id="20" name="Rectangle 19">
+            <a:extLst>
+              <a:ext uri="{FF2B5EF4-FFF2-40B4-BE49-F238E27FC236}">
+                <a16:creationId xmlns:a16="http://schemas.microsoft.com/office/drawing/2014/main" id="{F2B83EBA-39E3-C2CD-14F2-8A9AC6D158FC}"/>
               </a:ext>
             </a:extLst>
           </p:cNvPr>
@@ -3960,7 +3933,7 @@
         </p:nvSpPr>
         <p:spPr>
           <a:xfrm>
-            <a:off x="2115065" y="1206845"/>
+            <a:off x="284205" y="2351903"/>
             <a:ext cx="1830860" cy="520355"/>
           </a:xfrm>
           <a:prstGeom prst="rect">
@@ -3992,22 +3965,27 @@
           <a:p>
             <a:pPr algn="ctr"/>
             <a:r>
-              <a:rPr lang="en-US" dirty="0">
+              <a:rPr lang="en-US" u="sng" dirty="0" err="1">
                 <a:solidFill>
                   <a:sysClr val="windowText" lastClr="000000"/>
                 </a:solidFill>
               </a:rPr>
-              <a:t>Email</a:t>
-            </a:r>
-          </a:p>
-        </p:txBody>
-      </p:sp>
-      <p:sp>
-        <p:nvSpPr>
-          <p:cNvPr id="20" name="Rectangle 19">
-            <a:extLst>
-              <a:ext uri="{FF2B5EF4-FFF2-40B4-BE49-F238E27FC236}">
-                <a16:creationId xmlns:a16="http://schemas.microsoft.com/office/drawing/2014/main" id="{F2B83EBA-39E3-C2CD-14F2-8A9AC6D158FC}"/>
+              <a:t>SubscriptionID</a:t>
+            </a:r>
+            <a:endParaRPr lang="en-US" u="sng" dirty="0">
+              <a:solidFill>
+                <a:sysClr val="windowText" lastClr="000000"/>
+              </a:solidFill>
+            </a:endParaRPr>
+          </a:p>
+        </p:txBody>
+      </p:sp>
+      <p:sp>
+        <p:nvSpPr>
+          <p:cNvPr id="21" name="Rectangle 20">
+            <a:extLst>
+              <a:ext uri="{FF2B5EF4-FFF2-40B4-BE49-F238E27FC236}">
+                <a16:creationId xmlns:a16="http://schemas.microsoft.com/office/drawing/2014/main" id="{AF611E9B-2315-F4CD-EBE8-BC2E9340F49F}"/>
               </a:ext>
             </a:extLst>
           </p:cNvPr>
@@ -4016,7 +3994,7 @@
         </p:nvSpPr>
         <p:spPr>
           <a:xfrm>
-            <a:off x="284205" y="2351903"/>
+            <a:off x="2115065" y="2351902"/>
             <a:ext cx="1830860" cy="520355"/>
           </a:xfrm>
           <a:prstGeom prst="rect">
@@ -4048,27 +4026,22 @@
           <a:p>
             <a:pPr algn="ctr"/>
             <a:r>
-              <a:rPr lang="en-US" u="sng" dirty="0" err="1">
+              <a:rPr lang="en-US" dirty="0">
                 <a:solidFill>
                   <a:sysClr val="windowText" lastClr="000000"/>
                 </a:solidFill>
               </a:rPr>
-              <a:t>SubscriptionID</a:t>
-            </a:r>
-            <a:endParaRPr lang="en-US" u="sng" dirty="0">
-              <a:solidFill>
-                <a:sysClr val="windowText" lastClr="000000"/>
-              </a:solidFill>
-            </a:endParaRPr>
-          </a:p>
-        </p:txBody>
-      </p:sp>
-      <p:sp>
-        <p:nvSpPr>
-          <p:cNvPr id="21" name="Rectangle 20">
-            <a:extLst>
-              <a:ext uri="{FF2B5EF4-FFF2-40B4-BE49-F238E27FC236}">
-                <a16:creationId xmlns:a16="http://schemas.microsoft.com/office/drawing/2014/main" id="{AF611E9B-2315-F4CD-EBE8-BC2E9340F49F}"/>
+              <a:t>Status</a:t>
+            </a:r>
+          </a:p>
+        </p:txBody>
+      </p:sp>
+      <p:sp>
+        <p:nvSpPr>
+          <p:cNvPr id="22" name="Rectangle 21">
+            <a:extLst>
+              <a:ext uri="{FF2B5EF4-FFF2-40B4-BE49-F238E27FC236}">
+                <a16:creationId xmlns:a16="http://schemas.microsoft.com/office/drawing/2014/main" id="{B6336ACF-3835-2468-1DF1-8ABBCCBC2C23}"/>
               </a:ext>
             </a:extLst>
           </p:cNvPr>
@@ -4077,7 +4050,7 @@
         </p:nvSpPr>
         <p:spPr>
           <a:xfrm>
-            <a:off x="2115065" y="2351902"/>
+            <a:off x="3945925" y="2338173"/>
             <a:ext cx="1830860" cy="520355"/>
           </a:xfrm>
           <a:prstGeom prst="rect">
@@ -4114,17 +4087,17 @@
                   <a:sysClr val="windowText" lastClr="000000"/>
                 </a:solidFill>
               </a:rPr>
-              <a:t>Status</a:t>
-            </a:r>
-          </a:p>
-        </p:txBody>
-      </p:sp>
-      <p:sp>
-        <p:nvSpPr>
-          <p:cNvPr id="22" name="Rectangle 21">
-            <a:extLst>
-              <a:ext uri="{FF2B5EF4-FFF2-40B4-BE49-F238E27FC236}">
-                <a16:creationId xmlns:a16="http://schemas.microsoft.com/office/drawing/2014/main" id="{B6336ACF-3835-2468-1DF1-8ABBCCBC2C23}"/>
+              <a:t>StartDate</a:t>
+            </a:r>
+          </a:p>
+        </p:txBody>
+      </p:sp>
+      <p:sp>
+        <p:nvSpPr>
+          <p:cNvPr id="23" name="Rectangle 22">
+            <a:extLst>
+              <a:ext uri="{FF2B5EF4-FFF2-40B4-BE49-F238E27FC236}">
+                <a16:creationId xmlns:a16="http://schemas.microsoft.com/office/drawing/2014/main" id="{6A2C4DB0-655B-1C54-254E-B9582943BDAD}"/>
               </a:ext>
             </a:extLst>
           </p:cNvPr>
@@ -4133,7 +4106,7 @@
         </p:nvSpPr>
         <p:spPr>
           <a:xfrm>
-            <a:off x="3945925" y="2338173"/>
+            <a:off x="5776785" y="2324444"/>
             <a:ext cx="1830860" cy="520355"/>
           </a:xfrm>
           <a:prstGeom prst="rect">
@@ -4165,22 +4138,27 @@
           <a:p>
             <a:pPr algn="ctr"/>
             <a:r>
-              <a:rPr lang="en-US" dirty="0">
+              <a:rPr lang="en-US" dirty="0" err="1">
                 <a:solidFill>
                   <a:sysClr val="windowText" lastClr="000000"/>
                 </a:solidFill>
               </a:rPr>
-              <a:t>StartDate</a:t>
-            </a:r>
-          </a:p>
-        </p:txBody>
-      </p:sp>
-      <p:sp>
-        <p:nvSpPr>
-          <p:cNvPr id="23" name="Rectangle 22">
-            <a:extLst>
-              <a:ext uri="{FF2B5EF4-FFF2-40B4-BE49-F238E27FC236}">
-                <a16:creationId xmlns:a16="http://schemas.microsoft.com/office/drawing/2014/main" id="{6A2C4DB0-655B-1C54-254E-B9582943BDAD}"/>
+              <a:t>EndDate</a:t>
+            </a:r>
+            <a:endParaRPr lang="en-US" dirty="0">
+              <a:solidFill>
+                <a:sysClr val="windowText" lastClr="000000"/>
+              </a:solidFill>
+            </a:endParaRPr>
+          </a:p>
+        </p:txBody>
+      </p:sp>
+      <p:sp>
+        <p:nvSpPr>
+          <p:cNvPr id="24" name="Rectangle 23">
+            <a:extLst>
+              <a:ext uri="{FF2B5EF4-FFF2-40B4-BE49-F238E27FC236}">
+                <a16:creationId xmlns:a16="http://schemas.microsoft.com/office/drawing/2014/main" id="{7FF420FF-B34E-2939-C990-39775E391E94}"/>
               </a:ext>
             </a:extLst>
           </p:cNvPr>
@@ -4189,7 +4167,7 @@
         </p:nvSpPr>
         <p:spPr>
           <a:xfrm>
-            <a:off x="5776785" y="2324444"/>
+            <a:off x="284205" y="3488723"/>
             <a:ext cx="1830860" cy="520355"/>
           </a:xfrm>
           <a:prstGeom prst="rect">
@@ -4221,14 +4199,14 @@
           <a:p>
             <a:pPr algn="ctr"/>
             <a:r>
-              <a:rPr lang="en-US" dirty="0" err="1">
+              <a:rPr lang="en-US" u="sng" dirty="0" err="1">
                 <a:solidFill>
                   <a:sysClr val="windowText" lastClr="000000"/>
                 </a:solidFill>
               </a:rPr>
-              <a:t>EndDate</a:t>
-            </a:r>
-            <a:endParaRPr lang="en-US" dirty="0">
+              <a:t>PlanID</a:t>
+            </a:r>
+            <a:endParaRPr lang="en-US" u="sng" dirty="0">
               <a:solidFill>
                 <a:sysClr val="windowText" lastClr="000000"/>
               </a:solidFill>
@@ -4238,10 +4216,10 @@
       </p:sp>
       <p:sp>
         <p:nvSpPr>
-          <p:cNvPr id="24" name="Rectangle 23">
-            <a:extLst>
-              <a:ext uri="{FF2B5EF4-FFF2-40B4-BE49-F238E27FC236}">
-                <a16:creationId xmlns:a16="http://schemas.microsoft.com/office/drawing/2014/main" id="{7FF420FF-B34E-2939-C990-39775E391E94}"/>
+          <p:cNvPr id="25" name="Rectangle 24">
+            <a:extLst>
+              <a:ext uri="{FF2B5EF4-FFF2-40B4-BE49-F238E27FC236}">
+                <a16:creationId xmlns:a16="http://schemas.microsoft.com/office/drawing/2014/main" id="{F365C160-C575-7D51-6CC0-223EC39EEA3D}"/>
               </a:ext>
             </a:extLst>
           </p:cNvPr>
@@ -4250,7 +4228,7 @@
         </p:nvSpPr>
         <p:spPr>
           <a:xfrm>
-            <a:off x="284205" y="3488723"/>
+            <a:off x="2115065" y="3479794"/>
             <a:ext cx="1830860" cy="520355"/>
           </a:xfrm>
           <a:prstGeom prst="rect">
@@ -4282,14 +4260,14 @@
           <a:p>
             <a:pPr algn="ctr"/>
             <a:r>
-              <a:rPr lang="en-US" u="sng" dirty="0" err="1">
+              <a:rPr lang="en-US" dirty="0" err="1">
                 <a:solidFill>
                   <a:sysClr val="windowText" lastClr="000000"/>
                 </a:solidFill>
               </a:rPr>
-              <a:t>PlanID</a:t>
-            </a:r>
-            <a:endParaRPr lang="en-US" u="sng" dirty="0">
+              <a:t>PlanName</a:t>
+            </a:r>
+            <a:endParaRPr lang="en-US" dirty="0">
               <a:solidFill>
                 <a:sysClr val="windowText" lastClr="000000"/>
               </a:solidFill>
@@ -4299,10 +4277,10 @@
       </p:sp>
       <p:sp>
         <p:nvSpPr>
-          <p:cNvPr id="25" name="Rectangle 24">
-            <a:extLst>
-              <a:ext uri="{FF2B5EF4-FFF2-40B4-BE49-F238E27FC236}">
-                <a16:creationId xmlns:a16="http://schemas.microsoft.com/office/drawing/2014/main" id="{F365C160-C575-7D51-6CC0-223EC39EEA3D}"/>
+          <p:cNvPr id="26" name="Rectangle 25">
+            <a:extLst>
+              <a:ext uri="{FF2B5EF4-FFF2-40B4-BE49-F238E27FC236}">
+                <a16:creationId xmlns:a16="http://schemas.microsoft.com/office/drawing/2014/main" id="{6E42A316-EDF3-DD08-831A-DA07A0C1A514}"/>
               </a:ext>
             </a:extLst>
           </p:cNvPr>
@@ -4311,7 +4289,7 @@
         </p:nvSpPr>
         <p:spPr>
           <a:xfrm>
-            <a:off x="2115065" y="3479794"/>
+            <a:off x="3941807" y="3479794"/>
             <a:ext cx="1830860" cy="520355"/>
           </a:xfrm>
           <a:prstGeom prst="rect">
@@ -4348,7 +4326,7 @@
                   <a:sysClr val="windowText" lastClr="000000"/>
                 </a:solidFill>
               </a:rPr>
-              <a:t>PlanName</a:t>
+              <a:t>BillingPeriod</a:t>
             </a:r>
             <a:endParaRPr lang="en-US" dirty="0">
               <a:solidFill>
@@ -4360,10 +4338,10 @@
       </p:sp>
       <p:sp>
         <p:nvSpPr>
-          <p:cNvPr id="26" name="Rectangle 25">
-            <a:extLst>
-              <a:ext uri="{FF2B5EF4-FFF2-40B4-BE49-F238E27FC236}">
-                <a16:creationId xmlns:a16="http://schemas.microsoft.com/office/drawing/2014/main" id="{6E42A316-EDF3-DD08-831A-DA07A0C1A514}"/>
+          <p:cNvPr id="27" name="Rectangle 26">
+            <a:extLst>
+              <a:ext uri="{FF2B5EF4-FFF2-40B4-BE49-F238E27FC236}">
+                <a16:creationId xmlns:a16="http://schemas.microsoft.com/office/drawing/2014/main" id="{920981B6-A82F-E2D2-65C0-19CC1CFD8A30}"/>
               </a:ext>
             </a:extLst>
           </p:cNvPr>
@@ -4372,7 +4350,7 @@
         </p:nvSpPr>
         <p:spPr>
           <a:xfrm>
-            <a:off x="3941807" y="3479794"/>
+            <a:off x="5768549" y="3488723"/>
             <a:ext cx="1830860" cy="520355"/>
           </a:xfrm>
           <a:prstGeom prst="rect">
@@ -4409,7 +4387,7 @@
                   <a:sysClr val="windowText" lastClr="000000"/>
                 </a:solidFill>
               </a:rPr>
-              <a:t>BillingPeriod</a:t>
+              <a:t>AdFreeFlag</a:t>
             </a:r>
             <a:endParaRPr lang="en-US" dirty="0">
               <a:solidFill>
@@ -4421,10 +4399,10 @@
       </p:sp>
       <p:sp>
         <p:nvSpPr>
-          <p:cNvPr id="27" name="Rectangle 26">
-            <a:extLst>
-              <a:ext uri="{FF2B5EF4-FFF2-40B4-BE49-F238E27FC236}">
-                <a16:creationId xmlns:a16="http://schemas.microsoft.com/office/drawing/2014/main" id="{920981B6-A82F-E2D2-65C0-19CC1CFD8A30}"/>
+          <p:cNvPr id="28" name="Rectangle 27">
+            <a:extLst>
+              <a:ext uri="{FF2B5EF4-FFF2-40B4-BE49-F238E27FC236}">
+                <a16:creationId xmlns:a16="http://schemas.microsoft.com/office/drawing/2014/main" id="{F6DC679E-9D70-DEEF-08BD-977695CA4572}"/>
               </a:ext>
             </a:extLst>
           </p:cNvPr>
@@ -4433,7 +4411,7 @@
         </p:nvSpPr>
         <p:spPr>
           <a:xfrm>
-            <a:off x="5768549" y="3488723"/>
+            <a:off x="7599409" y="3479794"/>
             <a:ext cx="1830860" cy="520355"/>
           </a:xfrm>
           <a:prstGeom prst="rect">
@@ -4465,27 +4443,22 @@
           <a:p>
             <a:pPr algn="ctr"/>
             <a:r>
-              <a:rPr lang="en-US" dirty="0" err="1">
+              <a:rPr lang="en-US" dirty="0">
                 <a:solidFill>
                   <a:sysClr val="windowText" lastClr="000000"/>
                 </a:solidFill>
               </a:rPr>
-              <a:t>AdFreeFlag</a:t>
-            </a:r>
-            <a:endParaRPr lang="en-US" dirty="0">
-              <a:solidFill>
-                <a:sysClr val="windowText" lastClr="000000"/>
-              </a:solidFill>
-            </a:endParaRPr>
-          </a:p>
-        </p:txBody>
-      </p:sp>
-      <p:sp>
-        <p:nvSpPr>
-          <p:cNvPr id="28" name="Rectangle 27">
-            <a:extLst>
-              <a:ext uri="{FF2B5EF4-FFF2-40B4-BE49-F238E27FC236}">
-                <a16:creationId xmlns:a16="http://schemas.microsoft.com/office/drawing/2014/main" id="{F6DC679E-9D70-DEEF-08BD-977695CA4572}"/>
+              <a:t>Price</a:t>
+            </a:r>
+          </a:p>
+        </p:txBody>
+      </p:sp>
+      <p:sp>
+        <p:nvSpPr>
+          <p:cNvPr id="29" name="Rectangle 28">
+            <a:extLst>
+              <a:ext uri="{FF2B5EF4-FFF2-40B4-BE49-F238E27FC236}">
+                <a16:creationId xmlns:a16="http://schemas.microsoft.com/office/drawing/2014/main" id="{122638E2-9E29-396A-6C9B-4A1DFC4B78D7}"/>
               </a:ext>
             </a:extLst>
           </p:cNvPr>
@@ -4494,7 +4467,7 @@
         </p:nvSpPr>
         <p:spPr>
           <a:xfrm>
-            <a:off x="7599409" y="3479794"/>
+            <a:off x="284205" y="5806298"/>
             <a:ext cx="1830860" cy="520355"/>
           </a:xfrm>
           <a:prstGeom prst="rect">
@@ -4526,62 +4499,6 @@
           <a:p>
             <a:pPr algn="ctr"/>
             <a:r>
-              <a:rPr lang="en-US" dirty="0">
-                <a:solidFill>
-                  <a:sysClr val="windowText" lastClr="000000"/>
-                </a:solidFill>
-              </a:rPr>
-              <a:t>Price</a:t>
-            </a:r>
-          </a:p>
-        </p:txBody>
-      </p:sp>
-      <p:sp>
-        <p:nvSpPr>
-          <p:cNvPr id="29" name="Rectangle 28">
-            <a:extLst>
-              <a:ext uri="{FF2B5EF4-FFF2-40B4-BE49-F238E27FC236}">
-                <a16:creationId xmlns:a16="http://schemas.microsoft.com/office/drawing/2014/main" id="{122638E2-9E29-396A-6C9B-4A1DFC4B78D7}"/>
-              </a:ext>
-            </a:extLst>
-          </p:cNvPr>
-          <p:cNvSpPr/>
-          <p:nvPr/>
-        </p:nvSpPr>
-        <p:spPr>
-          <a:xfrm>
-            <a:off x="284205" y="5806298"/>
-            <a:ext cx="1830860" cy="520355"/>
-          </a:xfrm>
-          <a:prstGeom prst="rect">
-            <a:avLst/>
-          </a:prstGeom>
-          <a:solidFill>
-            <a:schemeClr val="bg1"/>
-          </a:solidFill>
-        </p:spPr>
-        <p:style>
-          <a:lnRef idx="2">
-            <a:schemeClr val="accent1">
-              <a:shade val="15000"/>
-            </a:schemeClr>
-          </a:lnRef>
-          <a:fillRef idx="1">
-            <a:schemeClr val="accent1"/>
-          </a:fillRef>
-          <a:effectRef idx="0">
-            <a:schemeClr val="accent1"/>
-          </a:effectRef>
-          <a:fontRef idx="minor">
-            <a:schemeClr val="lt1"/>
-          </a:fontRef>
-        </p:style>
-        <p:txBody>
-          <a:bodyPr rtlCol="0" anchor="ctr"/>
-          <a:lstStyle/>
-          <a:p>
-            <a:pPr algn="ctr"/>
-            <a:r>
               <a:rPr lang="en-US" u="sng" dirty="0" err="1">
                 <a:solidFill>
                   <a:sysClr val="windowText" lastClr="000000"/>
@@ -4590,189 +4507,6 @@
               <a:t>AdvertiserID</a:t>
             </a:r>
             <a:endParaRPr lang="en-US" u="sng" dirty="0">
-              <a:solidFill>
-                <a:sysClr val="windowText" lastClr="000000"/>
-              </a:solidFill>
-            </a:endParaRPr>
-          </a:p>
-        </p:txBody>
-      </p:sp>
-      <p:sp>
-        <p:nvSpPr>
-          <p:cNvPr id="30" name="Rectangle 29">
-            <a:extLst>
-              <a:ext uri="{FF2B5EF4-FFF2-40B4-BE49-F238E27FC236}">
-                <a16:creationId xmlns:a16="http://schemas.microsoft.com/office/drawing/2014/main" id="{A886307F-98A3-6EA0-CCCB-6F440B2D9A72}"/>
-              </a:ext>
-            </a:extLst>
-          </p:cNvPr>
-          <p:cNvSpPr/>
-          <p:nvPr/>
-        </p:nvSpPr>
-        <p:spPr>
-          <a:xfrm>
-            <a:off x="284205" y="4681147"/>
-            <a:ext cx="1830860" cy="520355"/>
-          </a:xfrm>
-          <a:prstGeom prst="rect">
-            <a:avLst/>
-          </a:prstGeom>
-          <a:solidFill>
-            <a:schemeClr val="bg1"/>
-          </a:solidFill>
-        </p:spPr>
-        <p:style>
-          <a:lnRef idx="2">
-            <a:schemeClr val="accent1">
-              <a:shade val="15000"/>
-            </a:schemeClr>
-          </a:lnRef>
-          <a:fillRef idx="1">
-            <a:schemeClr val="accent1"/>
-          </a:fillRef>
-          <a:effectRef idx="0">
-            <a:schemeClr val="accent1"/>
-          </a:effectRef>
-          <a:fontRef idx="minor">
-            <a:schemeClr val="lt1"/>
-          </a:fontRef>
-        </p:style>
-        <p:txBody>
-          <a:bodyPr rtlCol="0" anchor="ctr"/>
-          <a:lstStyle/>
-          <a:p>
-            <a:pPr algn="ctr"/>
-            <a:r>
-              <a:rPr lang="en-US" u="sng" dirty="0" err="1">
-                <a:solidFill>
-                  <a:sysClr val="windowText" lastClr="000000"/>
-                </a:solidFill>
-              </a:rPr>
-              <a:t>SessionID</a:t>
-            </a:r>
-            <a:endParaRPr lang="en-US" u="sng" dirty="0">
-              <a:solidFill>
-                <a:sysClr val="windowText" lastClr="000000"/>
-              </a:solidFill>
-            </a:endParaRPr>
-          </a:p>
-        </p:txBody>
-      </p:sp>
-      <p:sp>
-        <p:nvSpPr>
-          <p:cNvPr id="31" name="Rectangle 30">
-            <a:extLst>
-              <a:ext uri="{FF2B5EF4-FFF2-40B4-BE49-F238E27FC236}">
-                <a16:creationId xmlns:a16="http://schemas.microsoft.com/office/drawing/2014/main" id="{3233BE6A-E019-8907-DEDA-28C30437E684}"/>
-              </a:ext>
-            </a:extLst>
-          </p:cNvPr>
-          <p:cNvSpPr/>
-          <p:nvPr/>
-        </p:nvSpPr>
-        <p:spPr>
-          <a:xfrm>
-            <a:off x="2110947" y="4681146"/>
-            <a:ext cx="1830860" cy="520355"/>
-          </a:xfrm>
-          <a:prstGeom prst="rect">
-            <a:avLst/>
-          </a:prstGeom>
-          <a:solidFill>
-            <a:schemeClr val="bg1"/>
-          </a:solidFill>
-        </p:spPr>
-        <p:style>
-          <a:lnRef idx="2">
-            <a:schemeClr val="accent1">
-              <a:shade val="15000"/>
-            </a:schemeClr>
-          </a:lnRef>
-          <a:fillRef idx="1">
-            <a:schemeClr val="accent1"/>
-          </a:fillRef>
-          <a:effectRef idx="0">
-            <a:schemeClr val="accent1"/>
-          </a:effectRef>
-          <a:fontRef idx="minor">
-            <a:schemeClr val="lt1"/>
-          </a:fontRef>
-        </p:style>
-        <p:txBody>
-          <a:bodyPr rtlCol="0" anchor="ctr"/>
-          <a:lstStyle/>
-          <a:p>
-            <a:pPr algn="ctr"/>
-            <a:r>
-              <a:rPr lang="en-US" dirty="0" err="1">
-                <a:solidFill>
-                  <a:sysClr val="windowText" lastClr="000000"/>
-                </a:solidFill>
-              </a:rPr>
-              <a:t>StartedAt</a:t>
-            </a:r>
-            <a:endParaRPr lang="en-US" dirty="0">
-              <a:solidFill>
-                <a:sysClr val="windowText" lastClr="000000"/>
-              </a:solidFill>
-            </a:endParaRPr>
-          </a:p>
-        </p:txBody>
-      </p:sp>
-      <p:sp>
-        <p:nvSpPr>
-          <p:cNvPr id="33" name="Rectangle 32">
-            <a:extLst>
-              <a:ext uri="{FF2B5EF4-FFF2-40B4-BE49-F238E27FC236}">
-                <a16:creationId xmlns:a16="http://schemas.microsoft.com/office/drawing/2014/main" id="{0CF7859B-ABD9-44AF-DE3E-2E39743462BB}"/>
-              </a:ext>
-            </a:extLst>
-          </p:cNvPr>
-          <p:cNvSpPr/>
-          <p:nvPr/>
-        </p:nvSpPr>
-        <p:spPr>
-          <a:xfrm>
-            <a:off x="3937689" y="4681145"/>
-            <a:ext cx="1830860" cy="520355"/>
-          </a:xfrm>
-          <a:prstGeom prst="rect">
-            <a:avLst/>
-          </a:prstGeom>
-          <a:solidFill>
-            <a:schemeClr val="bg1"/>
-          </a:solidFill>
-        </p:spPr>
-        <p:style>
-          <a:lnRef idx="2">
-            <a:schemeClr val="accent1">
-              <a:shade val="15000"/>
-            </a:schemeClr>
-          </a:lnRef>
-          <a:fillRef idx="1">
-            <a:schemeClr val="accent1"/>
-          </a:fillRef>
-          <a:effectRef idx="0">
-            <a:schemeClr val="accent1"/>
-          </a:effectRef>
-          <a:fontRef idx="minor">
-            <a:schemeClr val="lt1"/>
-          </a:fontRef>
-        </p:style>
-        <p:txBody>
-          <a:bodyPr rtlCol="0" anchor="ctr"/>
-          <a:lstStyle/>
-          <a:p>
-            <a:pPr algn="ctr"/>
-            <a:r>
-              <a:rPr lang="en-US" dirty="0" err="1">
-                <a:solidFill>
-                  <a:sysClr val="windowText" lastClr="000000"/>
-                </a:solidFill>
-              </a:rPr>
-              <a:t>IsAdFreeAtStart</a:t>
-            </a:r>
-            <a:endParaRPr lang="en-US" dirty="0">
               <a:solidFill>
                 <a:sysClr val="windowText" lastClr="000000"/>
               </a:solidFill>
@@ -5064,7 +4798,7 @@
           </a:xfrm>
           <a:prstGeom prst="bentConnector3">
             <a:avLst>
-              <a:gd name="adj1" fmla="val 133756"/>
+              <a:gd name="adj1" fmla="val 49823"/>
             </a:avLst>
           </a:prstGeom>
           <a:ln>
@@ -5126,148 +4860,6 @@
           </a:p>
         </p:txBody>
       </p:sp>
-      <p:sp>
-        <p:nvSpPr>
-          <p:cNvPr id="46" name="Rectangle 45">
-            <a:extLst>
-              <a:ext uri="{FF2B5EF4-FFF2-40B4-BE49-F238E27FC236}">
-                <a16:creationId xmlns:a16="http://schemas.microsoft.com/office/drawing/2014/main" id="{39BA953E-D8A2-0BF2-643F-E87239931457}"/>
-              </a:ext>
-            </a:extLst>
-          </p:cNvPr>
-          <p:cNvSpPr/>
-          <p:nvPr/>
-        </p:nvSpPr>
-        <p:spPr>
-          <a:xfrm>
-            <a:off x="5776785" y="4681144"/>
-            <a:ext cx="1830860" cy="520355"/>
-          </a:xfrm>
-          <a:prstGeom prst="rect">
-            <a:avLst/>
-          </a:prstGeom>
-          <a:solidFill>
-            <a:schemeClr val="bg1"/>
-          </a:solidFill>
-        </p:spPr>
-        <p:style>
-          <a:lnRef idx="2">
-            <a:schemeClr val="accent1">
-              <a:shade val="15000"/>
-            </a:schemeClr>
-          </a:lnRef>
-          <a:fillRef idx="1">
-            <a:schemeClr val="accent1"/>
-          </a:fillRef>
-          <a:effectRef idx="0">
-            <a:schemeClr val="accent1"/>
-          </a:effectRef>
-          <a:fontRef idx="minor">
-            <a:schemeClr val="lt1"/>
-          </a:fontRef>
-        </p:style>
-        <p:txBody>
-          <a:bodyPr rtlCol="0" anchor="ctr"/>
-          <a:lstStyle/>
-          <a:p>
-            <a:pPr algn="ctr"/>
-            <a:r>
-              <a:rPr lang="en-US" dirty="0" err="1">
-                <a:solidFill>
-                  <a:sysClr val="windowText" lastClr="000000"/>
-                </a:solidFill>
-              </a:rPr>
-              <a:t>UserID</a:t>
-            </a:r>
-            <a:endParaRPr lang="en-US" dirty="0">
-              <a:solidFill>
-                <a:sysClr val="windowText" lastClr="000000"/>
-              </a:solidFill>
-            </a:endParaRPr>
-          </a:p>
-        </p:txBody>
-      </p:sp>
-      <p:sp>
-        <p:nvSpPr>
-          <p:cNvPr id="47" name="TextBox 46">
-            <a:extLst>
-              <a:ext uri="{FF2B5EF4-FFF2-40B4-BE49-F238E27FC236}">
-                <a16:creationId xmlns:a16="http://schemas.microsoft.com/office/drawing/2014/main" id="{46C5F4AF-CACE-669F-A79D-A1F99CEAA7F7}"/>
-              </a:ext>
-            </a:extLst>
-          </p:cNvPr>
-          <p:cNvSpPr txBox="1"/>
-          <p:nvPr/>
-        </p:nvSpPr>
-        <p:spPr>
-          <a:xfrm>
-            <a:off x="4070121" y="4279549"/>
-            <a:ext cx="5368384" cy="369332"/>
-          </a:xfrm>
-          <a:prstGeom prst="rect">
-            <a:avLst/>
-          </a:prstGeom>
-          <a:noFill/>
-        </p:spPr>
-        <p:txBody>
-          <a:bodyPr wrap="square" rtlCol="0">
-            <a:spAutoFit/>
-          </a:bodyPr>
-          <a:lstStyle/>
-          <a:p>
-            <a:pPr algn="ctr"/>
-            <a:r>
-              <a:rPr lang="en-US" dirty="0">
-                <a:solidFill>
-                  <a:schemeClr val="accent5"/>
-                </a:solidFill>
-              </a:rPr>
-              <a:t>Foreign Key</a:t>
-            </a:r>
-          </a:p>
-        </p:txBody>
-      </p:sp>
-      <p:cxnSp>
-        <p:nvCxnSpPr>
-          <p:cNvPr id="49" name="Straight Arrow Connector 48">
-            <a:extLst>
-              <a:ext uri="{FF2B5EF4-FFF2-40B4-BE49-F238E27FC236}">
-                <a16:creationId xmlns:a16="http://schemas.microsoft.com/office/drawing/2014/main" id="{F5A133F4-0C32-A4D9-A3E5-E287A51C6807}"/>
-              </a:ext>
-            </a:extLst>
-          </p:cNvPr>
-          <p:cNvCxnSpPr>
-            <a:endCxn id="18" idx="2"/>
-          </p:cNvCxnSpPr>
-          <p:nvPr/>
-        </p:nvCxnSpPr>
-        <p:spPr>
-          <a:xfrm flipH="1" flipV="1">
-            <a:off x="1199635" y="1735438"/>
-            <a:ext cx="5492580" cy="2913443"/>
-          </a:xfrm>
-          <a:prstGeom prst="straightConnector1">
-            <a:avLst/>
-          </a:prstGeom>
-          <a:ln>
-            <a:tailEnd type="triangle"/>
-          </a:ln>
-        </p:spPr>
-        <p:style>
-          <a:lnRef idx="2">
-            <a:schemeClr val="accent1"/>
-          </a:lnRef>
-          <a:fillRef idx="0">
-            <a:schemeClr val="accent1"/>
-          </a:fillRef>
-          <a:effectRef idx="1">
-            <a:schemeClr val="accent1"/>
-          </a:effectRef>
-          <a:fontRef idx="minor">
-            <a:schemeClr val="tx1"/>
-          </a:fontRef>
-        </p:style>
-      </p:cxnSp>
       <p:sp>
         <p:nvSpPr>
           <p:cNvPr id="50" name="Rectangle 49">
@@ -5906,10 +5498,10 @@
       </p:sp>
       <p:sp>
         <p:nvSpPr>
-          <p:cNvPr id="9" name="Rectangle 8">
-            <a:extLst>
-              <a:ext uri="{FF2B5EF4-FFF2-40B4-BE49-F238E27FC236}">
-                <a16:creationId xmlns:a16="http://schemas.microsoft.com/office/drawing/2014/main" id="{441239CC-2306-2F48-7597-C4CF64507BB5}"/>
+          <p:cNvPr id="11" name="Rectangle 10">
+            <a:extLst>
+              <a:ext uri="{FF2B5EF4-FFF2-40B4-BE49-F238E27FC236}">
+                <a16:creationId xmlns:a16="http://schemas.microsoft.com/office/drawing/2014/main" id="{BC85E758-CB03-89E2-A06F-FCDB30DBEB65}"/>
               </a:ext>
             </a:extLst>
           </p:cNvPr>
@@ -5918,17 +5510,14 @@
         </p:nvSpPr>
         <p:spPr>
           <a:xfrm>
-            <a:off x="177113" y="2378676"/>
-            <a:ext cx="11837773" cy="1050324"/>
+            <a:off x="288323" y="542325"/>
+            <a:ext cx="1830860" cy="520355"/>
           </a:xfrm>
           <a:prstGeom prst="rect">
             <a:avLst/>
           </a:prstGeom>
           <a:solidFill>
-            <a:schemeClr val="accent1">
-              <a:lumMod val="40000"/>
-              <a:lumOff val="60000"/>
-            </a:schemeClr>
+            <a:schemeClr val="bg1"/>
           </a:solidFill>
         </p:spPr>
         <p:style>
@@ -5952,52 +5541,28 @@
           <a:lstStyle/>
           <a:p>
             <a:pPr algn="ctr"/>
-            <a:endParaRPr lang="en-US"/>
-          </a:p>
-        </p:txBody>
-      </p:sp>
-      <p:sp>
-        <p:nvSpPr>
-          <p:cNvPr id="10" name="TextBox 9">
-            <a:extLst>
-              <a:ext uri="{FF2B5EF4-FFF2-40B4-BE49-F238E27FC236}">
-                <a16:creationId xmlns:a16="http://schemas.microsoft.com/office/drawing/2014/main" id="{8D5CEBE2-15A5-82DA-F011-22B4FB37A3C9}"/>
-              </a:ext>
-            </a:extLst>
-          </p:cNvPr>
-          <p:cNvSpPr txBox="1"/>
-          <p:nvPr/>
-        </p:nvSpPr>
-        <p:spPr>
-          <a:xfrm>
-            <a:off x="288323" y="2465172"/>
-            <a:ext cx="2038865" cy="369332"/>
-          </a:xfrm>
-          <a:prstGeom prst="rect">
-            <a:avLst/>
-          </a:prstGeom>
-          <a:noFill/>
-        </p:spPr>
-        <p:txBody>
-          <a:bodyPr wrap="square" rtlCol="0">
-            <a:spAutoFit/>
-          </a:bodyPr>
-          <a:lstStyle/>
-          <a:p>
-            <a:r>
-              <a:rPr lang="en-US" dirty="0" err="1"/>
-              <a:t>AdDelivery</a:t>
-            </a:r>
-            <a:endParaRPr lang="en-US" dirty="0"/>
-          </a:p>
-        </p:txBody>
-      </p:sp>
-      <p:sp>
-        <p:nvSpPr>
-          <p:cNvPr id="11" name="Rectangle 10">
-            <a:extLst>
-              <a:ext uri="{FF2B5EF4-FFF2-40B4-BE49-F238E27FC236}">
-                <a16:creationId xmlns:a16="http://schemas.microsoft.com/office/drawing/2014/main" id="{BC85E758-CB03-89E2-A06F-FCDB30DBEB65}"/>
+            <a:r>
+              <a:rPr lang="en-US" u="sng" dirty="0" err="1">
+                <a:solidFill>
+                  <a:sysClr val="windowText" lastClr="000000"/>
+                </a:solidFill>
+              </a:rPr>
+              <a:t>CampaignID</a:t>
+            </a:r>
+            <a:endParaRPr lang="en-US" u="sng" dirty="0">
+              <a:solidFill>
+                <a:sysClr val="windowText" lastClr="000000"/>
+              </a:solidFill>
+            </a:endParaRPr>
+          </a:p>
+        </p:txBody>
+      </p:sp>
+      <p:sp>
+        <p:nvSpPr>
+          <p:cNvPr id="12" name="Rectangle 11">
+            <a:extLst>
+              <a:ext uri="{FF2B5EF4-FFF2-40B4-BE49-F238E27FC236}">
+                <a16:creationId xmlns:a16="http://schemas.microsoft.com/office/drawing/2014/main" id="{E9B8B5DC-6B0A-4325-3457-E8CE229FD265}"/>
               </a:ext>
             </a:extLst>
           </p:cNvPr>
@@ -6006,7 +5571,7 @@
         </p:nvSpPr>
         <p:spPr>
           <a:xfrm>
-            <a:off x="288323" y="542325"/>
+            <a:off x="2119183" y="541639"/>
             <a:ext cx="1830860" cy="520355"/>
           </a:xfrm>
           <a:prstGeom prst="rect">
@@ -6038,27 +5603,22 @@
           <a:p>
             <a:pPr algn="ctr"/>
             <a:r>
-              <a:rPr lang="en-US" u="sng" dirty="0" err="1">
+              <a:rPr lang="en-US" dirty="0">
                 <a:solidFill>
                   <a:sysClr val="windowText" lastClr="000000"/>
                 </a:solidFill>
               </a:rPr>
-              <a:t>CampaignID</a:t>
-            </a:r>
-            <a:endParaRPr lang="en-US" u="sng" dirty="0">
-              <a:solidFill>
-                <a:sysClr val="windowText" lastClr="000000"/>
-              </a:solidFill>
-            </a:endParaRPr>
-          </a:p>
-        </p:txBody>
-      </p:sp>
-      <p:sp>
-        <p:nvSpPr>
-          <p:cNvPr id="12" name="Rectangle 11">
-            <a:extLst>
-              <a:ext uri="{FF2B5EF4-FFF2-40B4-BE49-F238E27FC236}">
-                <a16:creationId xmlns:a16="http://schemas.microsoft.com/office/drawing/2014/main" id="{E9B8B5DC-6B0A-4325-3457-E8CE229FD265}"/>
+              <a:t>Name</a:t>
+            </a:r>
+          </a:p>
+        </p:txBody>
+      </p:sp>
+      <p:sp>
+        <p:nvSpPr>
+          <p:cNvPr id="13" name="Rectangle 12">
+            <a:extLst>
+              <a:ext uri="{FF2B5EF4-FFF2-40B4-BE49-F238E27FC236}">
+                <a16:creationId xmlns:a16="http://schemas.microsoft.com/office/drawing/2014/main" id="{3DA87C26-10C7-9FF5-0D94-FC0E93BF3F91}"/>
               </a:ext>
             </a:extLst>
           </p:cNvPr>
@@ -6067,7 +5627,7 @@
         </p:nvSpPr>
         <p:spPr>
           <a:xfrm>
-            <a:off x="2119183" y="541639"/>
+            <a:off x="3950043" y="540953"/>
             <a:ext cx="1830860" cy="520355"/>
           </a:xfrm>
           <a:prstGeom prst="rect">
@@ -6104,17 +5664,17 @@
                   <a:sysClr val="windowText" lastClr="000000"/>
                 </a:solidFill>
               </a:rPr>
-              <a:t>Name</a:t>
-            </a:r>
-          </a:p>
-        </p:txBody>
-      </p:sp>
-      <p:sp>
-        <p:nvSpPr>
-          <p:cNvPr id="13" name="Rectangle 12">
-            <a:extLst>
-              <a:ext uri="{FF2B5EF4-FFF2-40B4-BE49-F238E27FC236}">
-                <a16:creationId xmlns:a16="http://schemas.microsoft.com/office/drawing/2014/main" id="{3DA87C26-10C7-9FF5-0D94-FC0E93BF3F91}"/>
+              <a:t>StartDate</a:t>
+            </a:r>
+          </a:p>
+        </p:txBody>
+      </p:sp>
+      <p:sp>
+        <p:nvSpPr>
+          <p:cNvPr id="14" name="Rectangle 13">
+            <a:extLst>
+              <a:ext uri="{FF2B5EF4-FFF2-40B4-BE49-F238E27FC236}">
+                <a16:creationId xmlns:a16="http://schemas.microsoft.com/office/drawing/2014/main" id="{CD64A636-B778-030A-C155-144901A432A4}"/>
               </a:ext>
             </a:extLst>
           </p:cNvPr>
@@ -6123,7 +5683,7 @@
         </p:nvSpPr>
         <p:spPr>
           <a:xfrm>
-            <a:off x="3950043" y="540953"/>
+            <a:off x="5780903" y="540267"/>
             <a:ext cx="1830860" cy="520355"/>
           </a:xfrm>
           <a:prstGeom prst="rect">
@@ -6155,22 +5715,27 @@
           <a:p>
             <a:pPr algn="ctr"/>
             <a:r>
-              <a:rPr lang="en-US" dirty="0">
+              <a:rPr lang="en-US" dirty="0" err="1">
                 <a:solidFill>
                   <a:sysClr val="windowText" lastClr="000000"/>
                 </a:solidFill>
               </a:rPr>
-              <a:t>StartDate</a:t>
-            </a:r>
-          </a:p>
-        </p:txBody>
-      </p:sp>
-      <p:sp>
-        <p:nvSpPr>
-          <p:cNvPr id="14" name="Rectangle 13">
-            <a:extLst>
-              <a:ext uri="{FF2B5EF4-FFF2-40B4-BE49-F238E27FC236}">
-                <a16:creationId xmlns:a16="http://schemas.microsoft.com/office/drawing/2014/main" id="{CD64A636-B778-030A-C155-144901A432A4}"/>
+              <a:t>EndDate</a:t>
+            </a:r>
+            <a:endParaRPr lang="en-US" dirty="0">
+              <a:solidFill>
+                <a:sysClr val="windowText" lastClr="000000"/>
+              </a:solidFill>
+            </a:endParaRPr>
+          </a:p>
+        </p:txBody>
+      </p:sp>
+      <p:sp>
+        <p:nvSpPr>
+          <p:cNvPr id="15" name="Rectangle 14">
+            <a:extLst>
+              <a:ext uri="{FF2B5EF4-FFF2-40B4-BE49-F238E27FC236}">
+                <a16:creationId xmlns:a16="http://schemas.microsoft.com/office/drawing/2014/main" id="{A2D6FA60-9F13-AE31-9370-7693FB57C09D}"/>
               </a:ext>
             </a:extLst>
           </p:cNvPr>
@@ -6179,7 +5744,7 @@
         </p:nvSpPr>
         <p:spPr>
           <a:xfrm>
-            <a:off x="5780903" y="540267"/>
+            <a:off x="288323" y="1641392"/>
             <a:ext cx="1830860" cy="520355"/>
           </a:xfrm>
           <a:prstGeom prst="rect">
@@ -6211,27 +5776,22 @@
           <a:p>
             <a:pPr algn="ctr"/>
             <a:r>
-              <a:rPr lang="en-US" dirty="0" err="1">
+              <a:rPr lang="en-US" u="sng" dirty="0">
                 <a:solidFill>
                   <a:sysClr val="windowText" lastClr="000000"/>
                 </a:solidFill>
               </a:rPr>
-              <a:t>EndDate</a:t>
-            </a:r>
-            <a:endParaRPr lang="en-US" dirty="0">
-              <a:solidFill>
-                <a:sysClr val="windowText" lastClr="000000"/>
-              </a:solidFill>
-            </a:endParaRPr>
-          </a:p>
-        </p:txBody>
-      </p:sp>
-      <p:sp>
-        <p:nvSpPr>
-          <p:cNvPr id="15" name="Rectangle 14">
-            <a:extLst>
-              <a:ext uri="{FF2B5EF4-FFF2-40B4-BE49-F238E27FC236}">
-                <a16:creationId xmlns:a16="http://schemas.microsoft.com/office/drawing/2014/main" id="{A2D6FA60-9F13-AE31-9370-7693FB57C09D}"/>
+              <a:t>AdID</a:t>
+            </a:r>
+          </a:p>
+        </p:txBody>
+      </p:sp>
+      <p:sp>
+        <p:nvSpPr>
+          <p:cNvPr id="16" name="Rectangle 15">
+            <a:extLst>
+              <a:ext uri="{FF2B5EF4-FFF2-40B4-BE49-F238E27FC236}">
+                <a16:creationId xmlns:a16="http://schemas.microsoft.com/office/drawing/2014/main" id="{F0A001F6-EBD1-787B-D6A1-A9C169A417D7}"/>
               </a:ext>
             </a:extLst>
           </p:cNvPr>
@@ -6240,7 +5800,7 @@
         </p:nvSpPr>
         <p:spPr>
           <a:xfrm>
-            <a:off x="288323" y="1641392"/>
+            <a:off x="2119183" y="1641392"/>
             <a:ext cx="1830860" cy="520355"/>
           </a:xfrm>
           <a:prstGeom prst="rect">
@@ -6272,22 +5832,27 @@
           <a:p>
             <a:pPr algn="ctr"/>
             <a:r>
-              <a:rPr lang="en-US" u="sng" dirty="0">
+              <a:rPr lang="en-US" dirty="0" err="1">
                 <a:solidFill>
                   <a:sysClr val="windowText" lastClr="000000"/>
                 </a:solidFill>
               </a:rPr>
-              <a:t>AdID</a:t>
-            </a:r>
-          </a:p>
-        </p:txBody>
-      </p:sp>
-      <p:sp>
-        <p:nvSpPr>
-          <p:cNvPr id="16" name="Rectangle 15">
-            <a:extLst>
-              <a:ext uri="{FF2B5EF4-FFF2-40B4-BE49-F238E27FC236}">
-                <a16:creationId xmlns:a16="http://schemas.microsoft.com/office/drawing/2014/main" id="{F0A001F6-EBD1-787B-D6A1-A9C169A417D7}"/>
+              <a:t>AdType</a:t>
+            </a:r>
+            <a:endParaRPr lang="en-US" dirty="0">
+              <a:solidFill>
+                <a:sysClr val="windowText" lastClr="000000"/>
+              </a:solidFill>
+            </a:endParaRPr>
+          </a:p>
+        </p:txBody>
+      </p:sp>
+      <p:sp>
+        <p:nvSpPr>
+          <p:cNvPr id="17" name="Rectangle 16">
+            <a:extLst>
+              <a:ext uri="{FF2B5EF4-FFF2-40B4-BE49-F238E27FC236}">
+                <a16:creationId xmlns:a16="http://schemas.microsoft.com/office/drawing/2014/main" id="{244FA49C-3449-F7E5-F950-A566DE6CC85E}"/>
               </a:ext>
             </a:extLst>
           </p:cNvPr>
@@ -6296,7 +5861,7 @@
         </p:nvSpPr>
         <p:spPr>
           <a:xfrm>
-            <a:off x="2119183" y="1641392"/>
+            <a:off x="3950043" y="1641392"/>
             <a:ext cx="1830860" cy="520355"/>
           </a:xfrm>
           <a:prstGeom prst="rect">
@@ -6333,7 +5898,7 @@
                   <a:sysClr val="windowText" lastClr="000000"/>
                 </a:solidFill>
               </a:rPr>
-              <a:t>AdType</a:t>
+              <a:t>DurationSec</a:t>
             </a:r>
             <a:endParaRPr lang="en-US" dirty="0">
               <a:solidFill>
@@ -6345,10 +5910,10 @@
       </p:sp>
       <p:sp>
         <p:nvSpPr>
-          <p:cNvPr id="17" name="Rectangle 16">
-            <a:extLst>
-              <a:ext uri="{FF2B5EF4-FFF2-40B4-BE49-F238E27FC236}">
-                <a16:creationId xmlns:a16="http://schemas.microsoft.com/office/drawing/2014/main" id="{244FA49C-3449-F7E5-F950-A566DE6CC85E}"/>
+          <p:cNvPr id="18" name="Rectangle 17">
+            <a:extLst>
+              <a:ext uri="{FF2B5EF4-FFF2-40B4-BE49-F238E27FC236}">
+                <a16:creationId xmlns:a16="http://schemas.microsoft.com/office/drawing/2014/main" id="{53B1751C-B794-9FC8-20F2-6B2628638673}"/>
               </a:ext>
             </a:extLst>
           </p:cNvPr>
@@ -6357,8 +5922,8 @@
         </p:nvSpPr>
         <p:spPr>
           <a:xfrm>
-            <a:off x="3950043" y="1641392"/>
-            <a:ext cx="1830860" cy="520355"/>
+            <a:off x="5780903" y="1640704"/>
+            <a:ext cx="1324232" cy="520355"/>
           </a:xfrm>
           <a:prstGeom prst="rect">
             <a:avLst/>
@@ -6394,7 +5959,7 @@
                   <a:sysClr val="windowText" lastClr="000000"/>
                 </a:solidFill>
               </a:rPr>
-              <a:t>DurationSec</a:t>
+              <a:t>PriceModel</a:t>
             </a:r>
             <a:endParaRPr lang="en-US" dirty="0">
               <a:solidFill>
@@ -6406,10 +5971,10 @@
       </p:sp>
       <p:sp>
         <p:nvSpPr>
-          <p:cNvPr id="18" name="Rectangle 17">
-            <a:extLst>
-              <a:ext uri="{FF2B5EF4-FFF2-40B4-BE49-F238E27FC236}">
-                <a16:creationId xmlns:a16="http://schemas.microsoft.com/office/drawing/2014/main" id="{53B1751C-B794-9FC8-20F2-6B2628638673}"/>
+          <p:cNvPr id="22" name="Rectangle 21">
+            <a:extLst>
+              <a:ext uri="{FF2B5EF4-FFF2-40B4-BE49-F238E27FC236}">
+                <a16:creationId xmlns:a16="http://schemas.microsoft.com/office/drawing/2014/main" id="{B0141EF1-672F-DFC1-EC6E-CC4CE4B4252B}"/>
               </a:ext>
             </a:extLst>
           </p:cNvPr>
@@ -6418,14 +5983,17 @@
         </p:nvSpPr>
         <p:spPr>
           <a:xfrm>
-            <a:off x="5780903" y="1640704"/>
-            <a:ext cx="1324232" cy="520355"/>
+            <a:off x="177113" y="3515496"/>
+            <a:ext cx="11837773" cy="1050324"/>
           </a:xfrm>
           <a:prstGeom prst="rect">
             <a:avLst/>
           </a:prstGeom>
           <a:solidFill>
-            <a:schemeClr val="bg1"/>
+            <a:schemeClr val="accent1">
+              <a:lumMod val="40000"/>
+              <a:lumOff val="60000"/>
+            </a:schemeClr>
           </a:solidFill>
         </p:spPr>
         <p:style>
@@ -6449,28 +6017,52 @@
           <a:lstStyle/>
           <a:p>
             <a:pPr algn="ctr"/>
-            <a:r>
-              <a:rPr lang="en-US" dirty="0" err="1">
-                <a:solidFill>
-                  <a:sysClr val="windowText" lastClr="000000"/>
-                </a:solidFill>
-              </a:rPr>
-              <a:t>PriceModel</a:t>
-            </a:r>
-            <a:endParaRPr lang="en-US" dirty="0">
-              <a:solidFill>
-                <a:sysClr val="windowText" lastClr="000000"/>
-              </a:solidFill>
-            </a:endParaRPr>
-          </a:p>
-        </p:txBody>
-      </p:sp>
-      <p:sp>
-        <p:nvSpPr>
-          <p:cNvPr id="19" name="Rectangle 18">
-            <a:extLst>
-              <a:ext uri="{FF2B5EF4-FFF2-40B4-BE49-F238E27FC236}">
-                <a16:creationId xmlns:a16="http://schemas.microsoft.com/office/drawing/2014/main" id="{7977BC3A-C4E6-DCBE-7BEF-5D5058F96921}"/>
+            <a:endParaRPr lang="en-US"/>
+          </a:p>
+        </p:txBody>
+      </p:sp>
+      <p:sp>
+        <p:nvSpPr>
+          <p:cNvPr id="23" name="TextBox 22">
+            <a:extLst>
+              <a:ext uri="{FF2B5EF4-FFF2-40B4-BE49-F238E27FC236}">
+                <a16:creationId xmlns:a16="http://schemas.microsoft.com/office/drawing/2014/main" id="{EA7F1E15-1B17-7073-DCC1-41A219A0E709}"/>
+              </a:ext>
+            </a:extLst>
+          </p:cNvPr>
+          <p:cNvSpPr txBox="1"/>
+          <p:nvPr/>
+        </p:nvSpPr>
+        <p:spPr>
+          <a:xfrm>
+            <a:off x="288323" y="3601992"/>
+            <a:ext cx="2038865" cy="369332"/>
+          </a:xfrm>
+          <a:prstGeom prst="rect">
+            <a:avLst/>
+          </a:prstGeom>
+          <a:noFill/>
+        </p:spPr>
+        <p:txBody>
+          <a:bodyPr wrap="square" rtlCol="0">
+            <a:spAutoFit/>
+          </a:bodyPr>
+          <a:lstStyle/>
+          <a:p>
+            <a:r>
+              <a:rPr lang="en-US" dirty="0" err="1"/>
+              <a:t>AdSlot</a:t>
+            </a:r>
+            <a:endParaRPr lang="en-US" dirty="0"/>
+          </a:p>
+        </p:txBody>
+      </p:sp>
+      <p:sp>
+        <p:nvSpPr>
+          <p:cNvPr id="24" name="Rectangle 23">
+            <a:extLst>
+              <a:ext uri="{FF2B5EF4-FFF2-40B4-BE49-F238E27FC236}">
+                <a16:creationId xmlns:a16="http://schemas.microsoft.com/office/drawing/2014/main" id="{68182469-83EA-02A8-C7FE-FAEFD6B9F3C2}"/>
               </a:ext>
             </a:extLst>
           </p:cNvPr>
@@ -6479,7 +6071,7 @@
         </p:nvSpPr>
         <p:spPr>
           <a:xfrm>
-            <a:off x="288323" y="2795374"/>
+            <a:off x="288323" y="3932194"/>
             <a:ext cx="1830860" cy="520355"/>
           </a:xfrm>
           <a:prstGeom prst="rect">
@@ -6516,7 +6108,7 @@
                   <a:sysClr val="windowText" lastClr="000000"/>
                 </a:solidFill>
               </a:rPr>
-              <a:t>DeliveryID</a:t>
+              <a:t>SlotSeqNo</a:t>
             </a:r>
             <a:endParaRPr lang="en-US" u="sng" dirty="0">
               <a:solidFill>
@@ -6528,10 +6120,10 @@
       </p:sp>
       <p:sp>
         <p:nvSpPr>
-          <p:cNvPr id="20" name="Rectangle 19">
-            <a:extLst>
-              <a:ext uri="{FF2B5EF4-FFF2-40B4-BE49-F238E27FC236}">
-                <a16:creationId xmlns:a16="http://schemas.microsoft.com/office/drawing/2014/main" id="{1C0E1198-8680-47E2-5A20-01ECF185BCC4}"/>
+          <p:cNvPr id="25" name="Rectangle 24">
+            <a:extLst>
+              <a:ext uri="{FF2B5EF4-FFF2-40B4-BE49-F238E27FC236}">
+                <a16:creationId xmlns:a16="http://schemas.microsoft.com/office/drawing/2014/main" id="{91787893-71A0-EBF1-5BC3-EEF23E07C31C}"/>
               </a:ext>
             </a:extLst>
           </p:cNvPr>
@@ -6540,7 +6132,7 @@
         </p:nvSpPr>
         <p:spPr>
           <a:xfrm>
-            <a:off x="7699289" y="2766541"/>
+            <a:off x="3355183" y="3927044"/>
             <a:ext cx="1830860" cy="520355"/>
           </a:xfrm>
           <a:prstGeom prst="rect">
@@ -6577,7 +6169,7 @@
                   <a:sysClr val="windowText" lastClr="000000"/>
                 </a:solidFill>
               </a:rPr>
-              <a:t>ServedAt</a:t>
+              <a:t>PlacementType</a:t>
             </a:r>
             <a:endParaRPr lang="en-US" dirty="0">
               <a:solidFill>
@@ -6589,10 +6181,10 @@
       </p:sp>
       <p:sp>
         <p:nvSpPr>
-          <p:cNvPr id="21" name="Rectangle 20">
-            <a:extLst>
-              <a:ext uri="{FF2B5EF4-FFF2-40B4-BE49-F238E27FC236}">
-                <a16:creationId xmlns:a16="http://schemas.microsoft.com/office/drawing/2014/main" id="{2227594E-1139-3B5B-1CFA-C3509CA71328}"/>
+          <p:cNvPr id="26" name="Rectangle 25">
+            <a:extLst>
+              <a:ext uri="{FF2B5EF4-FFF2-40B4-BE49-F238E27FC236}">
+                <a16:creationId xmlns:a16="http://schemas.microsoft.com/office/drawing/2014/main" id="{1F819B75-391E-275B-D1AF-A674061056DC}"/>
               </a:ext>
             </a:extLst>
           </p:cNvPr>
@@ -6601,8 +6193,8 @@
         </p:nvSpPr>
         <p:spPr>
           <a:xfrm>
-            <a:off x="9530149" y="2766541"/>
-            <a:ext cx="1830860" cy="520355"/>
+            <a:off x="5178117" y="3915892"/>
+            <a:ext cx="1510290" cy="520355"/>
           </a:xfrm>
           <a:prstGeom prst="rect">
             <a:avLst/>
@@ -6633,27 +6225,22 @@
           <a:p>
             <a:pPr algn="ctr"/>
             <a:r>
-              <a:rPr lang="en-US" dirty="0" err="1">
+              <a:rPr lang="en-US" dirty="0">
                 <a:solidFill>
                   <a:sysClr val="windowText" lastClr="000000"/>
                 </a:solidFill>
               </a:rPr>
-              <a:t>PricePaid</a:t>
-            </a:r>
-            <a:endParaRPr lang="en-US" dirty="0">
-              <a:solidFill>
-                <a:sysClr val="windowText" lastClr="000000"/>
-              </a:solidFill>
-            </a:endParaRPr>
-          </a:p>
-        </p:txBody>
-      </p:sp>
-      <p:sp>
-        <p:nvSpPr>
-          <p:cNvPr id="22" name="Rectangle 21">
-            <a:extLst>
-              <a:ext uri="{FF2B5EF4-FFF2-40B4-BE49-F238E27FC236}">
-                <a16:creationId xmlns:a16="http://schemas.microsoft.com/office/drawing/2014/main" id="{B0141EF1-672F-DFC1-EC6E-CC4CE4B4252B}"/>
+              <a:t>RequestedAt</a:t>
+            </a:r>
+          </a:p>
+        </p:txBody>
+      </p:sp>
+      <p:sp>
+        <p:nvSpPr>
+          <p:cNvPr id="27" name="Rectangle 26">
+            <a:extLst>
+              <a:ext uri="{FF2B5EF4-FFF2-40B4-BE49-F238E27FC236}">
+                <a16:creationId xmlns:a16="http://schemas.microsoft.com/office/drawing/2014/main" id="{70CEE439-642C-4636-F9F7-F9A7F0E3E3DF}"/>
               </a:ext>
             </a:extLst>
           </p:cNvPr>
@@ -6662,7 +6249,7 @@
         </p:nvSpPr>
         <p:spPr>
           <a:xfrm>
-            <a:off x="177113" y="3515496"/>
+            <a:off x="177113" y="4652316"/>
             <a:ext cx="11837773" cy="1050324"/>
           </a:xfrm>
           <a:prstGeom prst="rect">
@@ -6702,10 +6289,10 @@
       </p:sp>
       <p:sp>
         <p:nvSpPr>
-          <p:cNvPr id="23" name="TextBox 22">
-            <a:extLst>
-              <a:ext uri="{FF2B5EF4-FFF2-40B4-BE49-F238E27FC236}">
-                <a16:creationId xmlns:a16="http://schemas.microsoft.com/office/drawing/2014/main" id="{EA7F1E15-1B17-7073-DCC1-41A219A0E709}"/>
+          <p:cNvPr id="28" name="TextBox 27">
+            <a:extLst>
+              <a:ext uri="{FF2B5EF4-FFF2-40B4-BE49-F238E27FC236}">
+                <a16:creationId xmlns:a16="http://schemas.microsoft.com/office/drawing/2014/main" id="{51D8F6DA-5EC3-4F99-FE80-1935476D715F}"/>
               </a:ext>
             </a:extLst>
           </p:cNvPr>
@@ -6714,7 +6301,7 @@
         </p:nvSpPr>
         <p:spPr>
           <a:xfrm>
-            <a:off x="288323" y="3601992"/>
+            <a:off x="288323" y="4738812"/>
             <a:ext cx="2038865" cy="369332"/>
           </a:xfrm>
           <a:prstGeom prst="rect">
@@ -6730,7 +6317,7 @@
           <a:p>
             <a:r>
               <a:rPr lang="en-US" dirty="0" err="1"/>
-              <a:t>AdSlot</a:t>
+              <a:t>AdInteraction</a:t>
             </a:r>
             <a:endParaRPr lang="en-US" dirty="0"/>
           </a:p>
@@ -6738,10 +6325,10 @@
       </p:sp>
       <p:sp>
         <p:nvSpPr>
-          <p:cNvPr id="24" name="Rectangle 23">
-            <a:extLst>
-              <a:ext uri="{FF2B5EF4-FFF2-40B4-BE49-F238E27FC236}">
-                <a16:creationId xmlns:a16="http://schemas.microsoft.com/office/drawing/2014/main" id="{68182469-83EA-02A8-C7FE-FAEFD6B9F3C2}"/>
+          <p:cNvPr id="29" name="Rectangle 28">
+            <a:extLst>
+              <a:ext uri="{FF2B5EF4-FFF2-40B4-BE49-F238E27FC236}">
+                <a16:creationId xmlns:a16="http://schemas.microsoft.com/office/drawing/2014/main" id="{9382BC51-F060-B129-BE51-71465B4CDC00}"/>
               </a:ext>
             </a:extLst>
           </p:cNvPr>
@@ -6750,7 +6337,7 @@
         </p:nvSpPr>
         <p:spPr>
           <a:xfrm>
-            <a:off x="288323" y="3932194"/>
+            <a:off x="7599874" y="5050479"/>
             <a:ext cx="1830860" cy="520355"/>
           </a:xfrm>
           <a:prstGeom prst="rect">
@@ -6787,7 +6374,7 @@
                   <a:sysClr val="windowText" lastClr="000000"/>
                 </a:solidFill>
               </a:rPr>
-              <a:t>SlotSeqNo</a:t>
+              <a:t>EventSeqNo</a:t>
             </a:r>
             <a:endParaRPr lang="en-US" u="sng" dirty="0">
               <a:solidFill>
@@ -6799,10 +6386,10 @@
       </p:sp>
       <p:sp>
         <p:nvSpPr>
-          <p:cNvPr id="25" name="Rectangle 24">
-            <a:extLst>
-              <a:ext uri="{FF2B5EF4-FFF2-40B4-BE49-F238E27FC236}">
-                <a16:creationId xmlns:a16="http://schemas.microsoft.com/office/drawing/2014/main" id="{91787893-71A0-EBF1-5BC3-EEF23E07C31C}"/>
+          <p:cNvPr id="30" name="Rectangle 29">
+            <a:extLst>
+              <a:ext uri="{FF2B5EF4-FFF2-40B4-BE49-F238E27FC236}">
+                <a16:creationId xmlns:a16="http://schemas.microsoft.com/office/drawing/2014/main" id="{481BC8A4-1266-AB42-412D-38CF70AE987A}"/>
               </a:ext>
             </a:extLst>
           </p:cNvPr>
@@ -6811,7 +6398,7 @@
         </p:nvSpPr>
         <p:spPr>
           <a:xfrm>
-            <a:off x="3942117" y="3916745"/>
+            <a:off x="2119183" y="5050480"/>
             <a:ext cx="1830860" cy="520355"/>
           </a:xfrm>
           <a:prstGeom prst="rect">
@@ -6848,7 +6435,7 @@
                   <a:sysClr val="windowText" lastClr="000000"/>
                 </a:solidFill>
               </a:rPr>
-              <a:t>PlacementType</a:t>
+              <a:t>EventType</a:t>
             </a:r>
             <a:endParaRPr lang="en-US" dirty="0">
               <a:solidFill>
@@ -6860,10 +6447,10 @@
       </p:sp>
       <p:sp>
         <p:nvSpPr>
-          <p:cNvPr id="26" name="Rectangle 25">
-            <a:extLst>
-              <a:ext uri="{FF2B5EF4-FFF2-40B4-BE49-F238E27FC236}">
-                <a16:creationId xmlns:a16="http://schemas.microsoft.com/office/drawing/2014/main" id="{1F819B75-391E-275B-D1AF-A674061056DC}"/>
+          <p:cNvPr id="31" name="Rectangle 30">
+            <a:extLst>
+              <a:ext uri="{FF2B5EF4-FFF2-40B4-BE49-F238E27FC236}">
+                <a16:creationId xmlns:a16="http://schemas.microsoft.com/office/drawing/2014/main" id="{7EDF3083-E574-181C-77B2-977E7A5EA182}"/>
               </a:ext>
             </a:extLst>
           </p:cNvPr>
@@ -6872,7 +6459,7 @@
         </p:nvSpPr>
         <p:spPr>
           <a:xfrm>
-            <a:off x="5772977" y="3916745"/>
+            <a:off x="3950043" y="5050480"/>
             <a:ext cx="1830860" cy="520355"/>
           </a:xfrm>
           <a:prstGeom prst="rect">
@@ -6904,22 +6491,67 @@
           <a:p>
             <a:pPr algn="ctr"/>
             <a:r>
-              <a:rPr lang="en-US" dirty="0">
+              <a:rPr lang="en-US" dirty="0" err="1">
                 <a:solidFill>
                   <a:sysClr val="windowText" lastClr="000000"/>
                 </a:solidFill>
               </a:rPr>
-              <a:t>RequestedAt</a:t>
-            </a:r>
-          </a:p>
-        </p:txBody>
-      </p:sp>
-      <p:sp>
-        <p:nvSpPr>
-          <p:cNvPr id="27" name="Rectangle 26">
-            <a:extLst>
-              <a:ext uri="{FF2B5EF4-FFF2-40B4-BE49-F238E27FC236}">
-                <a16:creationId xmlns:a16="http://schemas.microsoft.com/office/drawing/2014/main" id="{70CEE439-642C-4636-F9F7-F9A7F0E3E3DF}"/>
+              <a:t>EventAt</a:t>
+            </a:r>
+            <a:endParaRPr lang="en-US" dirty="0">
+              <a:solidFill>
+                <a:sysClr val="windowText" lastClr="000000"/>
+              </a:solidFill>
+            </a:endParaRPr>
+          </a:p>
+        </p:txBody>
+      </p:sp>
+      <p:sp>
+        <p:nvSpPr>
+          <p:cNvPr id="33" name="TextBox 32">
+            <a:extLst>
+              <a:ext uri="{FF2B5EF4-FFF2-40B4-BE49-F238E27FC236}">
+                <a16:creationId xmlns:a16="http://schemas.microsoft.com/office/drawing/2014/main" id="{4CE7433C-510D-1AF0-322C-923C550004B4}"/>
+              </a:ext>
+            </a:extLst>
+          </p:cNvPr>
+          <p:cNvSpPr txBox="1"/>
+          <p:nvPr/>
+        </p:nvSpPr>
+        <p:spPr>
+          <a:xfrm>
+            <a:off x="5536453" y="3455772"/>
+            <a:ext cx="5368384" cy="369332"/>
+          </a:xfrm>
+          <a:prstGeom prst="rect">
+            <a:avLst/>
+          </a:prstGeom>
+          <a:noFill/>
+        </p:spPr>
+        <p:txBody>
+          <a:bodyPr wrap="square" rtlCol="0">
+            <a:spAutoFit/>
+          </a:bodyPr>
+          <a:lstStyle/>
+          <a:p>
+            <a:pPr algn="ctr"/>
+            <a:r>
+              <a:rPr lang="en-US" dirty="0">
+                <a:solidFill>
+                  <a:schemeClr val="accent5"/>
+                </a:solidFill>
+              </a:rPr>
+              <a:t>Foreign Key</a:t>
+            </a:r>
+          </a:p>
+        </p:txBody>
+      </p:sp>
+      <p:sp>
+        <p:nvSpPr>
+          <p:cNvPr id="42" name="Rectangle 41">
+            <a:extLst>
+              <a:ext uri="{FF2B5EF4-FFF2-40B4-BE49-F238E27FC236}">
+                <a16:creationId xmlns:a16="http://schemas.microsoft.com/office/drawing/2014/main" id="{981A791F-7087-E855-F9CC-94E63727D6F4}"/>
               </a:ext>
             </a:extLst>
           </p:cNvPr>
@@ -6928,17 +6560,14 @@
         </p:nvSpPr>
         <p:spPr>
           <a:xfrm>
-            <a:off x="177113" y="4652316"/>
-            <a:ext cx="11837773" cy="1050324"/>
+            <a:off x="7940259" y="3879337"/>
+            <a:ext cx="746541" cy="520355"/>
           </a:xfrm>
           <a:prstGeom prst="rect">
             <a:avLst/>
           </a:prstGeom>
           <a:solidFill>
-            <a:schemeClr val="accent1">
-              <a:lumMod val="40000"/>
-              <a:lumOff val="60000"/>
-            </a:schemeClr>
+            <a:schemeClr val="bg1"/>
           </a:solidFill>
         </p:spPr>
         <p:style>
@@ -6962,52 +6591,66 @@
           <a:lstStyle/>
           <a:p>
             <a:pPr algn="ctr"/>
-            <a:endParaRPr lang="en-US"/>
-          </a:p>
-        </p:txBody>
-      </p:sp>
-      <p:sp>
-        <p:nvSpPr>
-          <p:cNvPr id="28" name="TextBox 27">
-            <a:extLst>
-              <a:ext uri="{FF2B5EF4-FFF2-40B4-BE49-F238E27FC236}">
-                <a16:creationId xmlns:a16="http://schemas.microsoft.com/office/drawing/2014/main" id="{51D8F6DA-5EC3-4F99-FE80-1935476D715F}"/>
-              </a:ext>
-            </a:extLst>
-          </p:cNvPr>
-          <p:cNvSpPr txBox="1"/>
+            <a:r>
+              <a:rPr lang="en-US" u="sng" dirty="0">
+                <a:solidFill>
+                  <a:sysClr val="windowText" lastClr="000000"/>
+                </a:solidFill>
+              </a:rPr>
+              <a:t>AdID</a:t>
+            </a:r>
+          </a:p>
+        </p:txBody>
+      </p:sp>
+      <p:cxnSp>
+        <p:nvCxnSpPr>
+          <p:cNvPr id="45" name="Straight Arrow Connector 44">
+            <a:extLst>
+              <a:ext uri="{FF2B5EF4-FFF2-40B4-BE49-F238E27FC236}">
+                <a16:creationId xmlns:a16="http://schemas.microsoft.com/office/drawing/2014/main" id="{3496907B-CE97-97D9-A945-19A8F2E5C6B9}"/>
+              </a:ext>
+            </a:extLst>
+          </p:cNvPr>
+          <p:cNvCxnSpPr>
+            <a:cxnSpLocks/>
+            <a:stCxn id="42" idx="0"/>
+            <a:endCxn id="15" idx="2"/>
+          </p:cNvCxnSpPr>
           <p:nvPr/>
-        </p:nvSpPr>
-        <p:spPr>
-          <a:xfrm>
-            <a:off x="288323" y="4738812"/>
-            <a:ext cx="2038865" cy="369332"/>
-          </a:xfrm>
-          <a:prstGeom prst="rect">
-            <a:avLst/>
-          </a:prstGeom>
-          <a:noFill/>
-        </p:spPr>
-        <p:txBody>
-          <a:bodyPr wrap="square" rtlCol="0">
-            <a:spAutoFit/>
-          </a:bodyPr>
-          <a:lstStyle/>
-          <a:p>
-            <a:r>
-              <a:rPr lang="en-US" dirty="0" err="1"/>
-              <a:t>AdInteraction</a:t>
-            </a:r>
-            <a:endParaRPr lang="en-US" dirty="0"/>
-          </a:p>
-        </p:txBody>
-      </p:sp>
-      <p:sp>
-        <p:nvSpPr>
-          <p:cNvPr id="29" name="Rectangle 28">
-            <a:extLst>
-              <a:ext uri="{FF2B5EF4-FFF2-40B4-BE49-F238E27FC236}">
-                <a16:creationId xmlns:a16="http://schemas.microsoft.com/office/drawing/2014/main" id="{9382BC51-F060-B129-BE51-71465B4CDC00}"/>
+        </p:nvCxnSpPr>
+        <p:spPr>
+          <a:xfrm flipH="1" flipV="1">
+            <a:off x="1203753" y="2161747"/>
+            <a:ext cx="7109777" cy="1717590"/>
+          </a:xfrm>
+          <a:prstGeom prst="straightConnector1">
+            <a:avLst/>
+          </a:prstGeom>
+          <a:ln>
+            <a:tailEnd type="triangle"/>
+          </a:ln>
+        </p:spPr>
+        <p:style>
+          <a:lnRef idx="2">
+            <a:schemeClr val="accent1"/>
+          </a:lnRef>
+          <a:fillRef idx="0">
+            <a:schemeClr val="accent1"/>
+          </a:fillRef>
+          <a:effectRef idx="1">
+            <a:schemeClr val="accent1"/>
+          </a:effectRef>
+          <a:fontRef idx="minor">
+            <a:schemeClr val="tx1"/>
+          </a:fontRef>
+        </p:style>
+      </p:cxnSp>
+      <p:sp>
+        <p:nvSpPr>
+          <p:cNvPr id="46" name="Rectangle 45">
+            <a:extLst>
+              <a:ext uri="{FF2B5EF4-FFF2-40B4-BE49-F238E27FC236}">
+                <a16:creationId xmlns:a16="http://schemas.microsoft.com/office/drawing/2014/main" id="{C2A154E8-3E45-23CF-6440-1BB70A7C1CCF}"/>
               </a:ext>
             </a:extLst>
           </p:cNvPr>
@@ -7016,7 +6659,7 @@
         </p:nvSpPr>
         <p:spPr>
           <a:xfrm>
-            <a:off x="7599874" y="5050479"/>
+            <a:off x="5780903" y="5050479"/>
             <a:ext cx="1830860" cy="520355"/>
           </a:xfrm>
           <a:prstGeom prst="rect">
@@ -7053,7 +6696,7 @@
                   <a:sysClr val="windowText" lastClr="000000"/>
                 </a:solidFill>
               </a:rPr>
-              <a:t>EventSeqNo</a:t>
+              <a:t>DeliveryID</a:t>
             </a:r>
             <a:endParaRPr lang="en-US" u="sng" dirty="0">
               <a:solidFill>
@@ -7065,10 +6708,93 @@
       </p:sp>
       <p:sp>
         <p:nvSpPr>
-          <p:cNvPr id="30" name="Rectangle 29">
-            <a:extLst>
-              <a:ext uri="{FF2B5EF4-FFF2-40B4-BE49-F238E27FC236}">
-                <a16:creationId xmlns:a16="http://schemas.microsoft.com/office/drawing/2014/main" id="{481BC8A4-1266-AB42-412D-38CF70AE987A}"/>
+          <p:cNvPr id="47" name="TextBox 46">
+            <a:extLst>
+              <a:ext uri="{FF2B5EF4-FFF2-40B4-BE49-F238E27FC236}">
+                <a16:creationId xmlns:a16="http://schemas.microsoft.com/office/drawing/2014/main" id="{ED782714-6612-2CA4-870F-24D0721D6AAD}"/>
+              </a:ext>
+            </a:extLst>
+          </p:cNvPr>
+          <p:cNvSpPr txBox="1"/>
+          <p:nvPr/>
+        </p:nvSpPr>
+        <p:spPr>
+          <a:xfrm>
+            <a:off x="4066313" y="4712726"/>
+            <a:ext cx="5368384" cy="369332"/>
+          </a:xfrm>
+          <a:prstGeom prst="rect">
+            <a:avLst/>
+          </a:prstGeom>
+          <a:noFill/>
+        </p:spPr>
+        <p:txBody>
+          <a:bodyPr wrap="square" rtlCol="0">
+            <a:spAutoFit/>
+          </a:bodyPr>
+          <a:lstStyle/>
+          <a:p>
+            <a:pPr algn="ctr"/>
+            <a:r>
+              <a:rPr lang="en-US" dirty="0">
+                <a:solidFill>
+                  <a:schemeClr val="accent5"/>
+                </a:solidFill>
+              </a:rPr>
+              <a:t>Foreign Key</a:t>
+            </a:r>
+          </a:p>
+        </p:txBody>
+      </p:sp>
+      <p:cxnSp>
+        <p:nvCxnSpPr>
+          <p:cNvPr id="49" name="Straight Arrow Connector 48">
+            <a:extLst>
+              <a:ext uri="{FF2B5EF4-FFF2-40B4-BE49-F238E27FC236}">
+                <a16:creationId xmlns:a16="http://schemas.microsoft.com/office/drawing/2014/main" id="{429409E7-EFCE-4B93-1237-79C5043D35DA}"/>
+              </a:ext>
+            </a:extLst>
+          </p:cNvPr>
+          <p:cNvCxnSpPr>
+            <a:cxnSpLocks/>
+            <a:stCxn id="46" idx="0"/>
+            <a:endCxn id="19" idx="2"/>
+          </p:cNvCxnSpPr>
+          <p:nvPr/>
+        </p:nvCxnSpPr>
+        <p:spPr>
+          <a:xfrm flipV="1">
+            <a:off x="6696333" y="4429546"/>
+            <a:ext cx="618000" cy="620933"/>
+          </a:xfrm>
+          <a:prstGeom prst="straightConnector1">
+            <a:avLst/>
+          </a:prstGeom>
+          <a:ln>
+            <a:tailEnd type="triangle"/>
+          </a:ln>
+        </p:spPr>
+        <p:style>
+          <a:lnRef idx="2">
+            <a:schemeClr val="accent1"/>
+          </a:lnRef>
+          <a:fillRef idx="0">
+            <a:schemeClr val="accent1"/>
+          </a:fillRef>
+          <a:effectRef idx="1">
+            <a:schemeClr val="accent1"/>
+          </a:effectRef>
+          <a:fontRef idx="minor">
+            <a:schemeClr val="tx1"/>
+          </a:fontRef>
+        </p:style>
+      </p:cxnSp>
+      <p:sp>
+        <p:nvSpPr>
+          <p:cNvPr id="50" name="Rectangle 49">
+            <a:extLst>
+              <a:ext uri="{FF2B5EF4-FFF2-40B4-BE49-F238E27FC236}">
+                <a16:creationId xmlns:a16="http://schemas.microsoft.com/office/drawing/2014/main" id="{EAE6B7D5-0A4E-6860-18FE-E2DC521C7CBA}"/>
               </a:ext>
             </a:extLst>
           </p:cNvPr>
@@ -7077,8 +6803,8 @@
         </p:nvSpPr>
         <p:spPr>
           <a:xfrm>
-            <a:off x="2119183" y="5050480"/>
-            <a:ext cx="1830860" cy="520355"/>
+            <a:off x="7105135" y="1647057"/>
+            <a:ext cx="1441621" cy="520355"/>
           </a:xfrm>
           <a:prstGeom prst="rect">
             <a:avLst/>
@@ -7109,14 +6835,14 @@
           <a:p>
             <a:pPr algn="ctr"/>
             <a:r>
-              <a:rPr lang="en-US" dirty="0" err="1">
+              <a:rPr lang="en-US" u="sng" dirty="0" err="1">
                 <a:solidFill>
                   <a:sysClr val="windowText" lastClr="000000"/>
                 </a:solidFill>
               </a:rPr>
-              <a:t>EventType</a:t>
-            </a:r>
-            <a:endParaRPr lang="en-US" dirty="0">
+              <a:t>CampaignID</a:t>
+            </a:r>
+            <a:endParaRPr lang="en-US" u="sng" dirty="0">
               <a:solidFill>
                 <a:sysClr val="windowText" lastClr="000000"/>
               </a:solidFill>
@@ -7126,10 +6852,92 @@
       </p:sp>
       <p:sp>
         <p:nvSpPr>
-          <p:cNvPr id="31" name="Rectangle 30">
-            <a:extLst>
-              <a:ext uri="{FF2B5EF4-FFF2-40B4-BE49-F238E27FC236}">
-                <a16:creationId xmlns:a16="http://schemas.microsoft.com/office/drawing/2014/main" id="{7EDF3083-E574-181C-77B2-977E7A5EA182}"/>
+          <p:cNvPr id="51" name="TextBox 50">
+            <a:extLst>
+              <a:ext uri="{FF2B5EF4-FFF2-40B4-BE49-F238E27FC236}">
+                <a16:creationId xmlns:a16="http://schemas.microsoft.com/office/drawing/2014/main" id="{D580F992-D079-FD46-D39F-BCA23E98E570}"/>
+              </a:ext>
+            </a:extLst>
+          </p:cNvPr>
+          <p:cNvSpPr txBox="1"/>
+          <p:nvPr/>
+        </p:nvSpPr>
+        <p:spPr>
+          <a:xfrm>
+            <a:off x="5176363" y="1281502"/>
+            <a:ext cx="5368384" cy="369332"/>
+          </a:xfrm>
+          <a:prstGeom prst="rect">
+            <a:avLst/>
+          </a:prstGeom>
+          <a:noFill/>
+        </p:spPr>
+        <p:txBody>
+          <a:bodyPr wrap="square" rtlCol="0">
+            <a:spAutoFit/>
+          </a:bodyPr>
+          <a:lstStyle/>
+          <a:p>
+            <a:pPr algn="ctr"/>
+            <a:r>
+              <a:rPr lang="en-US" dirty="0">
+                <a:solidFill>
+                  <a:schemeClr val="accent5"/>
+                </a:solidFill>
+              </a:rPr>
+              <a:t>Foreign Key</a:t>
+            </a:r>
+          </a:p>
+        </p:txBody>
+      </p:sp>
+      <p:cxnSp>
+        <p:nvCxnSpPr>
+          <p:cNvPr id="53" name="Straight Arrow Connector 52">
+            <a:extLst>
+              <a:ext uri="{FF2B5EF4-FFF2-40B4-BE49-F238E27FC236}">
+                <a16:creationId xmlns:a16="http://schemas.microsoft.com/office/drawing/2014/main" id="{FD737468-A524-9B85-3B8A-D3FE14555DBC}"/>
+              </a:ext>
+            </a:extLst>
+          </p:cNvPr>
+          <p:cNvCxnSpPr>
+            <a:cxnSpLocks/>
+            <a:stCxn id="50" idx="0"/>
+          </p:cNvCxnSpPr>
+          <p:nvPr/>
+        </p:nvCxnSpPr>
+        <p:spPr>
+          <a:xfrm flipH="1" flipV="1">
+            <a:off x="315813" y="1060106"/>
+            <a:ext cx="7510133" cy="586951"/>
+          </a:xfrm>
+          <a:prstGeom prst="straightConnector1">
+            <a:avLst/>
+          </a:prstGeom>
+          <a:ln>
+            <a:tailEnd type="triangle"/>
+          </a:ln>
+        </p:spPr>
+        <p:style>
+          <a:lnRef idx="2">
+            <a:schemeClr val="accent1"/>
+          </a:lnRef>
+          <a:fillRef idx="0">
+            <a:schemeClr val="accent1"/>
+          </a:fillRef>
+          <a:effectRef idx="1">
+            <a:schemeClr val="accent1"/>
+          </a:effectRef>
+          <a:fontRef idx="minor">
+            <a:schemeClr val="tx1"/>
+          </a:fontRef>
+        </p:style>
+      </p:cxnSp>
+      <p:sp>
+        <p:nvSpPr>
+          <p:cNvPr id="54" name="Rectangle 53">
+            <a:extLst>
+              <a:ext uri="{FF2B5EF4-FFF2-40B4-BE49-F238E27FC236}">
+                <a16:creationId xmlns:a16="http://schemas.microsoft.com/office/drawing/2014/main" id="{3DA5AE8E-38F0-C792-5C0D-C4734DEDED40}"/>
               </a:ext>
             </a:extLst>
           </p:cNvPr>
@@ -7138,7 +6946,7 @@
         </p:nvSpPr>
         <p:spPr>
           <a:xfrm>
-            <a:off x="3950043" y="5050480"/>
+            <a:off x="7611763" y="541639"/>
             <a:ext cx="1830860" cy="520355"/>
           </a:xfrm>
           <a:prstGeom prst="rect">
@@ -7170,14 +6978,14 @@
           <a:p>
             <a:pPr algn="ctr"/>
             <a:r>
-              <a:rPr lang="en-US" dirty="0" err="1">
+              <a:rPr lang="en-US" u="sng" dirty="0" err="1">
                 <a:solidFill>
                   <a:sysClr val="windowText" lastClr="000000"/>
                 </a:solidFill>
               </a:rPr>
-              <a:t>EventAt</a:t>
-            </a:r>
-            <a:endParaRPr lang="en-US" dirty="0">
+              <a:t>AdvertiserID</a:t>
+            </a:r>
+            <a:endParaRPr lang="en-US" u="sng" dirty="0">
               <a:solidFill>
                 <a:sysClr val="windowText" lastClr="000000"/>
               </a:solidFill>
@@ -7187,10 +6995,50 @@
       </p:sp>
       <p:sp>
         <p:nvSpPr>
-          <p:cNvPr id="32" name="Rectangle 31">
-            <a:extLst>
-              <a:ext uri="{FF2B5EF4-FFF2-40B4-BE49-F238E27FC236}">
-                <a16:creationId xmlns:a16="http://schemas.microsoft.com/office/drawing/2014/main" id="{BB0F88A1-2C91-0560-0FCF-C74B030FCDCE}"/>
+          <p:cNvPr id="55" name="TextBox 54">
+            <a:extLst>
+              <a:ext uri="{FF2B5EF4-FFF2-40B4-BE49-F238E27FC236}">
+                <a16:creationId xmlns:a16="http://schemas.microsoft.com/office/drawing/2014/main" id="{50A077B9-B295-2C4D-56DB-5FC8D0F31D1C}"/>
+              </a:ext>
+            </a:extLst>
+          </p:cNvPr>
+          <p:cNvSpPr txBox="1"/>
+          <p:nvPr/>
+        </p:nvSpPr>
+        <p:spPr>
+          <a:xfrm>
+            <a:off x="5780903" y="236850"/>
+            <a:ext cx="5368384" cy="369332"/>
+          </a:xfrm>
+          <a:prstGeom prst="rect">
+            <a:avLst/>
+          </a:prstGeom>
+          <a:noFill/>
+        </p:spPr>
+        <p:txBody>
+          <a:bodyPr wrap="square" rtlCol="0">
+            <a:spAutoFit/>
+          </a:bodyPr>
+          <a:lstStyle/>
+          <a:p>
+            <a:pPr algn="ctr"/>
+            <a:r>
+              <a:rPr lang="en-US" dirty="0">
+                <a:solidFill>
+                  <a:schemeClr val="accent5"/>
+                </a:solidFill>
+              </a:rPr>
+              <a:t>Foreign Key</a:t>
+            </a:r>
+          </a:p>
+        </p:txBody>
+      </p:sp>
+      <p:sp>
+        <p:nvSpPr>
+          <p:cNvPr id="56" name="Right Brace 55">
+            <a:extLst>
+              <a:ext uri="{FF2B5EF4-FFF2-40B4-BE49-F238E27FC236}">
+                <a16:creationId xmlns:a16="http://schemas.microsoft.com/office/drawing/2014/main" id="{B122BDA6-8646-8870-DBA2-9C0923164180}"/>
               </a:ext>
             </a:extLst>
           </p:cNvPr>
@@ -7198,8 +7046,241 @@
           <p:nvPr/>
         </p:nvSpPr>
         <p:spPr>
-          <a:xfrm>
-            <a:off x="2111257" y="3927044"/>
+          <a:xfrm rot="5400000">
+            <a:off x="2082253" y="3620013"/>
+            <a:ext cx="358345" cy="1946532"/>
+          </a:xfrm>
+          <a:prstGeom prst="rightBrace">
+            <a:avLst/>
+          </a:prstGeom>
+        </p:spPr>
+        <p:style>
+          <a:lnRef idx="2">
+            <a:schemeClr val="accent1"/>
+          </a:lnRef>
+          <a:fillRef idx="0">
+            <a:schemeClr val="accent1"/>
+          </a:fillRef>
+          <a:effectRef idx="1">
+            <a:schemeClr val="accent1"/>
+          </a:effectRef>
+          <a:fontRef idx="minor">
+            <a:schemeClr val="tx1"/>
+          </a:fontRef>
+        </p:style>
+        <p:txBody>
+          <a:bodyPr rtlCol="0" anchor="ctr"/>
+          <a:lstStyle/>
+          <a:p>
+            <a:pPr algn="ctr"/>
+            <a:endParaRPr lang="en-US"/>
+          </a:p>
+        </p:txBody>
+      </p:sp>
+      <p:sp>
+        <p:nvSpPr>
+          <p:cNvPr id="57" name="TextBox 56">
+            <a:extLst>
+              <a:ext uri="{FF2B5EF4-FFF2-40B4-BE49-F238E27FC236}">
+                <a16:creationId xmlns:a16="http://schemas.microsoft.com/office/drawing/2014/main" id="{A0E0E682-9317-A3A5-10E7-A8066CA46D22}"/>
+              </a:ext>
+            </a:extLst>
+          </p:cNvPr>
+          <p:cNvSpPr txBox="1"/>
+          <p:nvPr/>
+        </p:nvSpPr>
+        <p:spPr>
+          <a:xfrm>
+            <a:off x="1915789" y="4648544"/>
+            <a:ext cx="3206801" cy="369332"/>
+          </a:xfrm>
+          <a:prstGeom prst="rect">
+            <a:avLst/>
+          </a:prstGeom>
+          <a:noFill/>
+        </p:spPr>
+        <p:txBody>
+          <a:bodyPr wrap="square" rtlCol="0">
+            <a:spAutoFit/>
+          </a:bodyPr>
+          <a:lstStyle/>
+          <a:p>
+            <a:r>
+              <a:rPr lang="en-US" dirty="0"/>
+              <a:t>Composite Primary Key</a:t>
+            </a:r>
+          </a:p>
+        </p:txBody>
+      </p:sp>
+      <p:sp>
+        <p:nvSpPr>
+          <p:cNvPr id="58" name="Right Brace 57">
+            <a:extLst>
+              <a:ext uri="{FF2B5EF4-FFF2-40B4-BE49-F238E27FC236}">
+                <a16:creationId xmlns:a16="http://schemas.microsoft.com/office/drawing/2014/main" id="{C9890756-AD6C-68E2-F4B5-68E41550EC47}"/>
+              </a:ext>
+            </a:extLst>
+          </p:cNvPr>
+          <p:cNvSpPr/>
+          <p:nvPr/>
+        </p:nvSpPr>
+        <p:spPr>
+          <a:xfrm rot="5400000">
+            <a:off x="7330897" y="4809345"/>
+            <a:ext cx="358345" cy="1946532"/>
+          </a:xfrm>
+          <a:prstGeom prst="rightBrace">
+            <a:avLst/>
+          </a:prstGeom>
+        </p:spPr>
+        <p:style>
+          <a:lnRef idx="2">
+            <a:schemeClr val="accent1"/>
+          </a:lnRef>
+          <a:fillRef idx="0">
+            <a:schemeClr val="accent1"/>
+          </a:fillRef>
+          <a:effectRef idx="1">
+            <a:schemeClr val="accent1"/>
+          </a:effectRef>
+          <a:fontRef idx="minor">
+            <a:schemeClr val="tx1"/>
+          </a:fontRef>
+        </p:style>
+        <p:txBody>
+          <a:bodyPr rtlCol="0" anchor="ctr"/>
+          <a:lstStyle/>
+          <a:p>
+            <a:pPr algn="ctr"/>
+            <a:endParaRPr lang="en-US"/>
+          </a:p>
+        </p:txBody>
+      </p:sp>
+      <p:sp>
+        <p:nvSpPr>
+          <p:cNvPr id="59" name="TextBox 58">
+            <a:extLst>
+              <a:ext uri="{FF2B5EF4-FFF2-40B4-BE49-F238E27FC236}">
+                <a16:creationId xmlns:a16="http://schemas.microsoft.com/office/drawing/2014/main" id="{1306BDD4-1934-3B89-BB32-65914A7169EF}"/>
+              </a:ext>
+            </a:extLst>
+          </p:cNvPr>
+          <p:cNvSpPr txBox="1"/>
+          <p:nvPr/>
+        </p:nvSpPr>
+        <p:spPr>
+          <a:xfrm>
+            <a:off x="6783859" y="5789136"/>
+            <a:ext cx="3206801" cy="369332"/>
+          </a:xfrm>
+          <a:prstGeom prst="rect">
+            <a:avLst/>
+          </a:prstGeom>
+          <a:noFill/>
+        </p:spPr>
+        <p:txBody>
+          <a:bodyPr wrap="square" rtlCol="0">
+            <a:spAutoFit/>
+          </a:bodyPr>
+          <a:lstStyle/>
+          <a:p>
+            <a:r>
+              <a:rPr lang="en-US" dirty="0"/>
+              <a:t>Composite Primary Key</a:t>
+            </a:r>
+          </a:p>
+        </p:txBody>
+      </p:sp>
+      <p:sp>
+        <p:nvSpPr>
+          <p:cNvPr id="68" name="TextBox 67">
+            <a:extLst>
+              <a:ext uri="{FF2B5EF4-FFF2-40B4-BE49-F238E27FC236}">
+                <a16:creationId xmlns:a16="http://schemas.microsoft.com/office/drawing/2014/main" id="{785F16E7-9E75-A17F-FA2D-FFCFBEDAEA54}"/>
+              </a:ext>
+            </a:extLst>
+          </p:cNvPr>
+          <p:cNvSpPr txBox="1"/>
+          <p:nvPr/>
+        </p:nvSpPr>
+        <p:spPr>
+          <a:xfrm>
+            <a:off x="4949879" y="6732715"/>
+            <a:ext cx="3206801" cy="369332"/>
+          </a:xfrm>
+          <a:prstGeom prst="rect">
+            <a:avLst/>
+          </a:prstGeom>
+          <a:noFill/>
+        </p:spPr>
+        <p:txBody>
+          <a:bodyPr wrap="square" rtlCol="0">
+            <a:spAutoFit/>
+          </a:bodyPr>
+          <a:lstStyle/>
+          <a:p>
+            <a:r>
+              <a:rPr lang="en-US" dirty="0"/>
+              <a:t>Composite Primary Key</a:t>
+            </a:r>
+          </a:p>
+        </p:txBody>
+      </p:sp>
+      <p:sp>
+        <p:nvSpPr>
+          <p:cNvPr id="69" name="TextBox 68">
+            <a:extLst>
+              <a:ext uri="{FF2B5EF4-FFF2-40B4-BE49-F238E27FC236}">
+                <a16:creationId xmlns:a16="http://schemas.microsoft.com/office/drawing/2014/main" id="{DA17DFD0-9E0A-8E05-49AC-43469205A876}"/>
+              </a:ext>
+            </a:extLst>
+          </p:cNvPr>
+          <p:cNvSpPr txBox="1"/>
+          <p:nvPr/>
+        </p:nvSpPr>
+        <p:spPr>
+          <a:xfrm>
+            <a:off x="2207850" y="5854344"/>
+            <a:ext cx="5368384" cy="369332"/>
+          </a:xfrm>
+          <a:prstGeom prst="rect">
+            <a:avLst/>
+          </a:prstGeom>
+          <a:noFill/>
+        </p:spPr>
+        <p:txBody>
+          <a:bodyPr wrap="square" rtlCol="0">
+            <a:spAutoFit/>
+          </a:bodyPr>
+          <a:lstStyle/>
+          <a:p>
+            <a:pPr algn="ctr"/>
+            <a:r>
+              <a:rPr lang="en-US" dirty="0">
+                <a:solidFill>
+                  <a:schemeClr val="accent5"/>
+                </a:solidFill>
+              </a:rPr>
+              <a:t>Foreign Key</a:t>
+            </a:r>
+          </a:p>
+        </p:txBody>
+      </p:sp>
+      <p:sp>
+        <p:nvSpPr>
+          <p:cNvPr id="70" name="Rectangle 69">
+            <a:extLst>
+              <a:ext uri="{FF2B5EF4-FFF2-40B4-BE49-F238E27FC236}">
+                <a16:creationId xmlns:a16="http://schemas.microsoft.com/office/drawing/2014/main" id="{50A9C9AB-DF32-52D7-D9B8-5B41B078DF06}"/>
+              </a:ext>
+            </a:extLst>
+          </p:cNvPr>
+          <p:cNvSpPr/>
+          <p:nvPr/>
+        </p:nvSpPr>
+        <p:spPr>
+          <a:xfrm>
+            <a:off x="7664901" y="6143360"/>
             <a:ext cx="1830860" cy="520355"/>
           </a:xfrm>
           <a:prstGeom prst="rect">
@@ -7236,7 +7317,7 @@
                   <a:sysClr val="windowText" lastClr="000000"/>
                 </a:solidFill>
               </a:rPr>
-              <a:t>SessionID</a:t>
+              <a:t>TxnType</a:t>
             </a:r>
             <a:endParaRPr lang="en-US" dirty="0">
               <a:solidFill>
@@ -7248,50 +7329,10 @@
       </p:sp>
       <p:sp>
         <p:nvSpPr>
-          <p:cNvPr id="33" name="TextBox 32">
-            <a:extLst>
-              <a:ext uri="{FF2B5EF4-FFF2-40B4-BE49-F238E27FC236}">
-                <a16:creationId xmlns:a16="http://schemas.microsoft.com/office/drawing/2014/main" id="{4CE7433C-510D-1AF0-322C-923C550004B4}"/>
-              </a:ext>
-            </a:extLst>
-          </p:cNvPr>
-          <p:cNvSpPr txBox="1"/>
-          <p:nvPr/>
-        </p:nvSpPr>
-        <p:spPr>
-          <a:xfrm>
-            <a:off x="342495" y="3568008"/>
-            <a:ext cx="5368384" cy="369332"/>
-          </a:xfrm>
-          <a:prstGeom prst="rect">
-            <a:avLst/>
-          </a:prstGeom>
-          <a:noFill/>
-        </p:spPr>
-        <p:txBody>
-          <a:bodyPr wrap="square" rtlCol="0">
-            <a:spAutoFit/>
-          </a:bodyPr>
-          <a:lstStyle/>
-          <a:p>
-            <a:pPr algn="ctr"/>
-            <a:r>
-              <a:rPr lang="en-US" dirty="0">
-                <a:solidFill>
-                  <a:schemeClr val="accent5"/>
-                </a:solidFill>
-              </a:rPr>
-              <a:t>Foreign Key</a:t>
-            </a:r>
-          </a:p>
-        </p:txBody>
-      </p:sp>
-      <p:sp>
-        <p:nvSpPr>
-          <p:cNvPr id="35" name="Rectangle 34">
-            <a:extLst>
-              <a:ext uri="{FF2B5EF4-FFF2-40B4-BE49-F238E27FC236}">
-                <a16:creationId xmlns:a16="http://schemas.microsoft.com/office/drawing/2014/main" id="{A04D1282-CE61-3541-B719-42D90739FF41}"/>
+          <p:cNvPr id="72" name="Rectangle 71">
+            <a:extLst>
+              <a:ext uri="{FF2B5EF4-FFF2-40B4-BE49-F238E27FC236}">
+                <a16:creationId xmlns:a16="http://schemas.microsoft.com/office/drawing/2014/main" id="{9D682B5A-30AD-FED8-19A1-DF1FD0CB1DA3}"/>
               </a:ext>
             </a:extLst>
           </p:cNvPr>
@@ -7300,7 +7341,7 @@
         </p:nvSpPr>
         <p:spPr>
           <a:xfrm>
-            <a:off x="2152952" y="2783188"/>
+            <a:off x="9497822" y="6150914"/>
             <a:ext cx="1830860" cy="520355"/>
           </a:xfrm>
           <a:prstGeom prst="rect">
@@ -7332,14 +7373,14 @@
           <a:p>
             <a:pPr algn="ctr"/>
             <a:r>
-              <a:rPr lang="en-US" u="sng" dirty="0" err="1">
+              <a:rPr lang="en-US" dirty="0" err="1">
                 <a:solidFill>
                   <a:sysClr val="windowText" lastClr="000000"/>
                 </a:solidFill>
               </a:rPr>
-              <a:t>SlotSeqNo</a:t>
-            </a:r>
-            <a:endParaRPr lang="en-US" u="sng" dirty="0">
+              <a:t>TxnDateTime</a:t>
+            </a:r>
+            <a:endParaRPr lang="en-US" dirty="0">
               <a:solidFill>
                 <a:sysClr val="windowText" lastClr="000000"/>
               </a:solidFill>
@@ -7349,10 +7390,10 @@
       </p:sp>
       <p:sp>
         <p:nvSpPr>
-          <p:cNvPr id="36" name="Rectangle 35">
-            <a:extLst>
-              <a:ext uri="{FF2B5EF4-FFF2-40B4-BE49-F238E27FC236}">
-                <a16:creationId xmlns:a16="http://schemas.microsoft.com/office/drawing/2014/main" id="{6E48746D-942B-32C7-962B-752FC1F0CB8A}"/>
+          <p:cNvPr id="73" name="Rectangle 72">
+            <a:extLst>
+              <a:ext uri="{FF2B5EF4-FFF2-40B4-BE49-F238E27FC236}">
+                <a16:creationId xmlns:a16="http://schemas.microsoft.com/office/drawing/2014/main" id="{42BFFA77-00D9-FADB-56FB-61C6742812F7}"/>
               </a:ext>
             </a:extLst>
           </p:cNvPr>
@@ -7361,8 +7402,8 @@
         </p:nvSpPr>
         <p:spPr>
           <a:xfrm>
-            <a:off x="3983812" y="2776319"/>
-            <a:ext cx="1830860" cy="520355"/>
+            <a:off x="8546756" y="1647057"/>
+            <a:ext cx="1441621" cy="520355"/>
           </a:xfrm>
           <a:prstGeom prst="rect">
             <a:avLst/>
@@ -7398,7 +7439,7 @@
                   <a:sysClr val="windowText" lastClr="000000"/>
                 </a:solidFill>
               </a:rPr>
-              <a:t>SessionID</a:t>
+              <a:t>BidAmount</a:t>
             </a:r>
             <a:endParaRPr lang="en-US" dirty="0">
               <a:solidFill>
@@ -7410,92 +7451,10 @@
       </p:sp>
       <p:sp>
         <p:nvSpPr>
-          <p:cNvPr id="37" name="TextBox 36">
-            <a:extLst>
-              <a:ext uri="{FF2B5EF4-FFF2-40B4-BE49-F238E27FC236}">
-                <a16:creationId xmlns:a16="http://schemas.microsoft.com/office/drawing/2014/main" id="{DEE78217-0026-0299-C922-BE36E6F83A66}"/>
-              </a:ext>
-            </a:extLst>
-          </p:cNvPr>
-          <p:cNvSpPr txBox="1"/>
-          <p:nvPr/>
-        </p:nvSpPr>
-        <p:spPr>
-          <a:xfrm>
-            <a:off x="1145787" y="2399440"/>
-            <a:ext cx="5368384" cy="369332"/>
-          </a:xfrm>
-          <a:prstGeom prst="rect">
-            <a:avLst/>
-          </a:prstGeom>
-          <a:noFill/>
-        </p:spPr>
-        <p:txBody>
-          <a:bodyPr wrap="square" rtlCol="0">
-            <a:spAutoFit/>
-          </a:bodyPr>
-          <a:lstStyle/>
-          <a:p>
-            <a:pPr algn="ctr"/>
-            <a:r>
-              <a:rPr lang="en-US" dirty="0">
-                <a:solidFill>
-                  <a:schemeClr val="accent5"/>
-                </a:solidFill>
-              </a:rPr>
-              <a:t>Foreign Key</a:t>
-            </a:r>
-          </a:p>
-        </p:txBody>
-      </p:sp>
-      <p:cxnSp>
-        <p:nvCxnSpPr>
-          <p:cNvPr id="39" name="Straight Arrow Connector 38">
-            <a:extLst>
-              <a:ext uri="{FF2B5EF4-FFF2-40B4-BE49-F238E27FC236}">
-                <a16:creationId xmlns:a16="http://schemas.microsoft.com/office/drawing/2014/main" id="{B97DF107-D49E-BD8D-0479-1CC3E3C0AAB0}"/>
-              </a:ext>
-            </a:extLst>
-          </p:cNvPr>
-          <p:cNvCxnSpPr>
-            <a:cxnSpLocks/>
-            <a:endCxn id="24" idx="0"/>
-          </p:cNvCxnSpPr>
-          <p:nvPr/>
-        </p:nvCxnSpPr>
-        <p:spPr>
-          <a:xfrm flipH="1">
-            <a:off x="1203753" y="3271449"/>
-            <a:ext cx="5580106" cy="660745"/>
-          </a:xfrm>
-          <a:prstGeom prst="straightConnector1">
-            <a:avLst/>
-          </a:prstGeom>
-          <a:ln>
-            <a:tailEnd type="triangle"/>
-          </a:ln>
-        </p:spPr>
-        <p:style>
-          <a:lnRef idx="2">
-            <a:schemeClr val="accent1"/>
-          </a:lnRef>
-          <a:fillRef idx="0">
-            <a:schemeClr val="accent1"/>
-          </a:fillRef>
-          <a:effectRef idx="1">
-            <a:schemeClr val="accent1"/>
-          </a:effectRef>
-          <a:fontRef idx="minor">
-            <a:schemeClr val="tx1"/>
-          </a:fontRef>
-        </p:style>
-      </p:cxnSp>
-      <p:sp>
-        <p:nvSpPr>
-          <p:cNvPr id="42" name="Rectangle 41">
-            <a:extLst>
-              <a:ext uri="{FF2B5EF4-FFF2-40B4-BE49-F238E27FC236}">
-                <a16:creationId xmlns:a16="http://schemas.microsoft.com/office/drawing/2014/main" id="{981A791F-7087-E855-F9CC-94E63727D6F4}"/>
+          <p:cNvPr id="74" name="Rectangle 73">
+            <a:extLst>
+              <a:ext uri="{FF2B5EF4-FFF2-40B4-BE49-F238E27FC236}">
+                <a16:creationId xmlns:a16="http://schemas.microsoft.com/office/drawing/2014/main" id="{672E052E-68EA-A418-758B-3873256A4953}"/>
               </a:ext>
             </a:extLst>
           </p:cNvPr>
@@ -7504,7 +7463,7 @@
         </p:nvSpPr>
         <p:spPr>
           <a:xfrm>
-            <a:off x="5814672" y="2771171"/>
+            <a:off x="9989407" y="1640703"/>
             <a:ext cx="1830860" cy="520355"/>
           </a:xfrm>
           <a:prstGeom prst="rect">
@@ -7536,104 +7495,27 @@
           <a:p>
             <a:pPr algn="ctr"/>
             <a:r>
-              <a:rPr lang="en-US" u="sng" dirty="0">
+              <a:rPr lang="en-US" dirty="0" err="1">
                 <a:solidFill>
                   <a:sysClr val="windowText" lastClr="000000"/>
                 </a:solidFill>
               </a:rPr>
-              <a:t>AdID</a:t>
-            </a:r>
-          </a:p>
-        </p:txBody>
-      </p:sp>
-      <p:sp>
-        <p:nvSpPr>
-          <p:cNvPr id="43" name="TextBox 42">
-            <a:extLst>
-              <a:ext uri="{FF2B5EF4-FFF2-40B4-BE49-F238E27FC236}">
-                <a16:creationId xmlns:a16="http://schemas.microsoft.com/office/drawing/2014/main" id="{735958C4-EEB7-CF18-F515-BCBB7A906363}"/>
-              </a:ext>
-            </a:extLst>
-          </p:cNvPr>
-          <p:cNvSpPr txBox="1"/>
-          <p:nvPr/>
-        </p:nvSpPr>
-        <p:spPr>
-          <a:xfrm>
-            <a:off x="2438398" y="2353961"/>
-            <a:ext cx="5368384" cy="369332"/>
-          </a:xfrm>
-          <a:prstGeom prst="rect">
-            <a:avLst/>
-          </a:prstGeom>
-          <a:noFill/>
-        </p:spPr>
-        <p:txBody>
-          <a:bodyPr wrap="square" rtlCol="0">
-            <a:spAutoFit/>
-          </a:bodyPr>
-          <a:lstStyle/>
-          <a:p>
-            <a:pPr algn="ctr"/>
-            <a:r>
-              <a:rPr lang="en-US" dirty="0">
-                <a:solidFill>
-                  <a:schemeClr val="accent5"/>
-                </a:solidFill>
-              </a:rPr>
-              <a:t>Foreign Key</a:t>
-            </a:r>
-          </a:p>
-        </p:txBody>
-      </p:sp>
-      <p:cxnSp>
-        <p:nvCxnSpPr>
-          <p:cNvPr id="45" name="Straight Arrow Connector 44">
-            <a:extLst>
-              <a:ext uri="{FF2B5EF4-FFF2-40B4-BE49-F238E27FC236}">
-                <a16:creationId xmlns:a16="http://schemas.microsoft.com/office/drawing/2014/main" id="{3496907B-CE97-97D9-A945-19A8F2E5C6B9}"/>
-              </a:ext>
-            </a:extLst>
-          </p:cNvPr>
-          <p:cNvCxnSpPr>
-            <a:stCxn id="42" idx="0"/>
-            <a:endCxn id="15" idx="2"/>
-          </p:cNvCxnSpPr>
-          <p:nvPr/>
-        </p:nvCxnSpPr>
-        <p:spPr>
-          <a:xfrm flipH="1" flipV="1">
-            <a:off x="1203753" y="2161747"/>
-            <a:ext cx="5526349" cy="609424"/>
-          </a:xfrm>
-          <a:prstGeom prst="straightConnector1">
-            <a:avLst/>
-          </a:prstGeom>
-          <a:ln>
-            <a:tailEnd type="triangle"/>
-          </a:ln>
-        </p:spPr>
-        <p:style>
-          <a:lnRef idx="2">
-            <a:schemeClr val="accent1"/>
-          </a:lnRef>
-          <a:fillRef idx="0">
-            <a:schemeClr val="accent1"/>
-          </a:fillRef>
-          <a:effectRef idx="1">
-            <a:schemeClr val="accent1"/>
-          </a:effectRef>
-          <a:fontRef idx="minor">
-            <a:schemeClr val="tx1"/>
-          </a:fontRef>
-        </p:style>
-      </p:cxnSp>
-      <p:sp>
-        <p:nvSpPr>
-          <p:cNvPr id="46" name="Rectangle 45">
-            <a:extLst>
-              <a:ext uri="{FF2B5EF4-FFF2-40B4-BE49-F238E27FC236}">
-                <a16:creationId xmlns:a16="http://schemas.microsoft.com/office/drawing/2014/main" id="{C2A154E8-3E45-23CF-6440-1BB70A7C1CCF}"/>
+              <a:t>ClickURL</a:t>
+            </a:r>
+            <a:endParaRPr lang="en-US" dirty="0">
+              <a:solidFill>
+                <a:sysClr val="windowText" lastClr="000000"/>
+              </a:solidFill>
+            </a:endParaRPr>
+          </a:p>
+        </p:txBody>
+      </p:sp>
+      <p:sp>
+        <p:nvSpPr>
+          <p:cNvPr id="75" name="Rectangle 74">
+            <a:extLst>
+              <a:ext uri="{FF2B5EF4-FFF2-40B4-BE49-F238E27FC236}">
+                <a16:creationId xmlns:a16="http://schemas.microsoft.com/office/drawing/2014/main" id="{7FDA21C2-751C-92EE-5B5F-54145413A477}"/>
               </a:ext>
             </a:extLst>
           </p:cNvPr>
@@ -7642,7 +7524,7 @@
         </p:nvSpPr>
         <p:spPr>
           <a:xfrm>
-            <a:off x="5780903" y="5050479"/>
+            <a:off x="9430734" y="547647"/>
             <a:ext cx="1830860" cy="520355"/>
           </a:xfrm>
           <a:prstGeom prst="rect">
@@ -7674,109 +7556,22 @@
           <a:p>
             <a:pPr algn="ctr"/>
             <a:r>
-              <a:rPr lang="en-US" u="sng" dirty="0" err="1">
+              <a:rPr lang="en-US" dirty="0">
                 <a:solidFill>
                   <a:sysClr val="windowText" lastClr="000000"/>
                 </a:solidFill>
               </a:rPr>
-              <a:t>DeliveryID</a:t>
-            </a:r>
-            <a:endParaRPr lang="en-US" u="sng" dirty="0">
-              <a:solidFill>
-                <a:sysClr val="windowText" lastClr="000000"/>
-              </a:solidFill>
-            </a:endParaRPr>
-          </a:p>
-        </p:txBody>
-      </p:sp>
-      <p:sp>
-        <p:nvSpPr>
-          <p:cNvPr id="47" name="TextBox 46">
-            <a:extLst>
-              <a:ext uri="{FF2B5EF4-FFF2-40B4-BE49-F238E27FC236}">
-                <a16:creationId xmlns:a16="http://schemas.microsoft.com/office/drawing/2014/main" id="{ED782714-6612-2CA4-870F-24D0721D6AAD}"/>
-              </a:ext>
-            </a:extLst>
-          </p:cNvPr>
-          <p:cNvSpPr txBox="1"/>
-          <p:nvPr/>
-        </p:nvSpPr>
-        <p:spPr>
-          <a:xfrm>
-            <a:off x="4066313" y="4712726"/>
-            <a:ext cx="5368384" cy="369332"/>
-          </a:xfrm>
-          <a:prstGeom prst="rect">
-            <a:avLst/>
-          </a:prstGeom>
-          <a:noFill/>
-        </p:spPr>
-        <p:txBody>
-          <a:bodyPr wrap="square" rtlCol="0">
-            <a:spAutoFit/>
-          </a:bodyPr>
-          <a:lstStyle/>
-          <a:p>
-            <a:pPr algn="ctr"/>
-            <a:r>
-              <a:rPr lang="en-US" dirty="0">
-                <a:solidFill>
-                  <a:schemeClr val="accent5"/>
-                </a:solidFill>
-              </a:rPr>
-              <a:t>Foreign Key</a:t>
-            </a:r>
-          </a:p>
-        </p:txBody>
-      </p:sp>
-      <p:cxnSp>
-        <p:nvCxnSpPr>
-          <p:cNvPr id="49" name="Straight Arrow Connector 48">
-            <a:extLst>
-              <a:ext uri="{FF2B5EF4-FFF2-40B4-BE49-F238E27FC236}">
-                <a16:creationId xmlns:a16="http://schemas.microsoft.com/office/drawing/2014/main" id="{429409E7-EFCE-4B93-1237-79C5043D35DA}"/>
-              </a:ext>
-            </a:extLst>
-          </p:cNvPr>
-          <p:cNvCxnSpPr>
-            <a:stCxn id="46" idx="0"/>
-            <a:endCxn id="19" idx="2"/>
-          </p:cNvCxnSpPr>
-          <p:nvPr/>
-        </p:nvCxnSpPr>
-        <p:spPr>
-          <a:xfrm flipH="1" flipV="1">
-            <a:off x="1203753" y="3315729"/>
-            <a:ext cx="5492580" cy="1734750"/>
-          </a:xfrm>
-          <a:prstGeom prst="straightConnector1">
-            <a:avLst/>
-          </a:prstGeom>
-          <a:ln>
-            <a:tailEnd type="triangle"/>
-          </a:ln>
-        </p:spPr>
-        <p:style>
-          <a:lnRef idx="2">
-            <a:schemeClr val="accent1"/>
-          </a:lnRef>
-          <a:fillRef idx="0">
-            <a:schemeClr val="accent1"/>
-          </a:fillRef>
-          <a:effectRef idx="1">
-            <a:schemeClr val="accent1"/>
-          </a:effectRef>
-          <a:fontRef idx="minor">
-            <a:schemeClr val="tx1"/>
-          </a:fontRef>
-        </p:style>
-      </p:cxnSp>
-      <p:sp>
-        <p:nvSpPr>
-          <p:cNvPr id="50" name="Rectangle 49">
-            <a:extLst>
-              <a:ext uri="{FF2B5EF4-FFF2-40B4-BE49-F238E27FC236}">
-                <a16:creationId xmlns:a16="http://schemas.microsoft.com/office/drawing/2014/main" id="{EAE6B7D5-0A4E-6860-18FE-E2DC521C7CBA}"/>
+              <a:t>Budget</a:t>
+            </a:r>
+          </a:p>
+        </p:txBody>
+      </p:sp>
+      <p:sp>
+        <p:nvSpPr>
+          <p:cNvPr id="19" name="Rectangle 18">
+            <a:extLst>
+              <a:ext uri="{FF2B5EF4-FFF2-40B4-BE49-F238E27FC236}">
+                <a16:creationId xmlns:a16="http://schemas.microsoft.com/office/drawing/2014/main" id="{7977BC3A-C4E6-DCBE-7BEF-5D5058F96921}"/>
               </a:ext>
             </a:extLst>
           </p:cNvPr>
@@ -7785,8 +7580,8 @@
         </p:nvSpPr>
         <p:spPr>
           <a:xfrm>
-            <a:off x="7105135" y="1647057"/>
-            <a:ext cx="1441621" cy="520355"/>
+            <a:off x="6688407" y="3909191"/>
+            <a:ext cx="1251852" cy="520355"/>
           </a:xfrm>
           <a:prstGeom prst="rect">
             <a:avLst/>
@@ -7822,7 +7617,7 @@
                   <a:sysClr val="windowText" lastClr="000000"/>
                 </a:solidFill>
               </a:rPr>
-              <a:t>CampaignID</a:t>
+              <a:t>DeliveryID</a:t>
             </a:r>
             <a:endParaRPr lang="en-US" u="sng" dirty="0">
               <a:solidFill>
@@ -7834,92 +7629,10 @@
       </p:sp>
       <p:sp>
         <p:nvSpPr>
-          <p:cNvPr id="51" name="TextBox 50">
-            <a:extLst>
-              <a:ext uri="{FF2B5EF4-FFF2-40B4-BE49-F238E27FC236}">
-                <a16:creationId xmlns:a16="http://schemas.microsoft.com/office/drawing/2014/main" id="{D580F992-D079-FD46-D39F-BCA23E98E570}"/>
-              </a:ext>
-            </a:extLst>
-          </p:cNvPr>
-          <p:cNvSpPr txBox="1"/>
-          <p:nvPr/>
-        </p:nvSpPr>
-        <p:spPr>
-          <a:xfrm>
-            <a:off x="5176363" y="1281502"/>
-            <a:ext cx="5368384" cy="369332"/>
-          </a:xfrm>
-          <a:prstGeom prst="rect">
-            <a:avLst/>
-          </a:prstGeom>
-          <a:noFill/>
-        </p:spPr>
-        <p:txBody>
-          <a:bodyPr wrap="square" rtlCol="0">
-            <a:spAutoFit/>
-          </a:bodyPr>
-          <a:lstStyle/>
-          <a:p>
-            <a:pPr algn="ctr"/>
-            <a:r>
-              <a:rPr lang="en-US" dirty="0">
-                <a:solidFill>
-                  <a:schemeClr val="accent5"/>
-                </a:solidFill>
-              </a:rPr>
-              <a:t>Foreign Key</a:t>
-            </a:r>
-          </a:p>
-        </p:txBody>
-      </p:sp>
-      <p:cxnSp>
-        <p:nvCxnSpPr>
-          <p:cNvPr id="53" name="Straight Arrow Connector 52">
-            <a:extLst>
-              <a:ext uri="{FF2B5EF4-FFF2-40B4-BE49-F238E27FC236}">
-                <a16:creationId xmlns:a16="http://schemas.microsoft.com/office/drawing/2014/main" id="{FD737468-A524-9B85-3B8A-D3FE14555DBC}"/>
-              </a:ext>
-            </a:extLst>
-          </p:cNvPr>
-          <p:cNvCxnSpPr>
-            <a:cxnSpLocks/>
-            <a:stCxn id="50" idx="0"/>
-          </p:cNvCxnSpPr>
-          <p:nvPr/>
-        </p:nvCxnSpPr>
-        <p:spPr>
-          <a:xfrm flipH="1" flipV="1">
-            <a:off x="315813" y="1060106"/>
-            <a:ext cx="7510133" cy="586951"/>
-          </a:xfrm>
-          <a:prstGeom prst="straightConnector1">
-            <a:avLst/>
-          </a:prstGeom>
-          <a:ln>
-            <a:tailEnd type="triangle"/>
-          </a:ln>
-        </p:spPr>
-        <p:style>
-          <a:lnRef idx="2">
-            <a:schemeClr val="accent1"/>
-          </a:lnRef>
-          <a:fillRef idx="0">
-            <a:schemeClr val="accent1"/>
-          </a:fillRef>
-          <a:effectRef idx="1">
-            <a:schemeClr val="accent1"/>
-          </a:effectRef>
-          <a:fontRef idx="minor">
-            <a:schemeClr val="tx1"/>
-          </a:fontRef>
-        </p:style>
-      </p:cxnSp>
-      <p:sp>
-        <p:nvSpPr>
-          <p:cNvPr id="54" name="Rectangle 53">
-            <a:extLst>
-              <a:ext uri="{FF2B5EF4-FFF2-40B4-BE49-F238E27FC236}">
-                <a16:creationId xmlns:a16="http://schemas.microsoft.com/office/drawing/2014/main" id="{3DA5AE8E-38F0-C792-5C0D-C4734DEDED40}"/>
+          <p:cNvPr id="20" name="Rectangle 19">
+            <a:extLst>
+              <a:ext uri="{FF2B5EF4-FFF2-40B4-BE49-F238E27FC236}">
+                <a16:creationId xmlns:a16="http://schemas.microsoft.com/office/drawing/2014/main" id="{1C0E1198-8680-47E2-5A20-01ECF185BCC4}"/>
               </a:ext>
             </a:extLst>
           </p:cNvPr>
@@ -7928,8 +7641,8 @@
         </p:nvSpPr>
         <p:spPr>
           <a:xfrm>
-            <a:off x="7611763" y="541639"/>
-            <a:ext cx="1830860" cy="520355"/>
+            <a:off x="8686800" y="3876932"/>
+            <a:ext cx="1079164" cy="520355"/>
           </a:xfrm>
           <a:prstGeom prst="rect">
             <a:avLst/>
@@ -7960,14 +7673,14 @@
           <a:p>
             <a:pPr algn="ctr"/>
             <a:r>
-              <a:rPr lang="en-US" u="sng" dirty="0" err="1">
+              <a:rPr lang="en-US" dirty="0" err="1">
                 <a:solidFill>
                   <a:sysClr val="windowText" lastClr="000000"/>
                 </a:solidFill>
               </a:rPr>
-              <a:t>AdvertiserID</a:t>
-            </a:r>
-            <a:endParaRPr lang="en-US" u="sng" dirty="0">
+              <a:t>ServedAt</a:t>
+            </a:r>
+            <a:endParaRPr lang="en-US" dirty="0">
               <a:solidFill>
                 <a:sysClr val="windowText" lastClr="000000"/>
               </a:solidFill>
@@ -7977,50 +7690,10 @@
       </p:sp>
       <p:sp>
         <p:nvSpPr>
-          <p:cNvPr id="55" name="TextBox 54">
-            <a:extLst>
-              <a:ext uri="{FF2B5EF4-FFF2-40B4-BE49-F238E27FC236}">
-                <a16:creationId xmlns:a16="http://schemas.microsoft.com/office/drawing/2014/main" id="{50A077B9-B295-2C4D-56DB-5FC8D0F31D1C}"/>
-              </a:ext>
-            </a:extLst>
-          </p:cNvPr>
-          <p:cNvSpPr txBox="1"/>
-          <p:nvPr/>
-        </p:nvSpPr>
-        <p:spPr>
-          <a:xfrm>
-            <a:off x="5780903" y="236850"/>
-            <a:ext cx="5368384" cy="369332"/>
-          </a:xfrm>
-          <a:prstGeom prst="rect">
-            <a:avLst/>
-          </a:prstGeom>
-          <a:noFill/>
-        </p:spPr>
-        <p:txBody>
-          <a:bodyPr wrap="square" rtlCol="0">
-            <a:spAutoFit/>
-          </a:bodyPr>
-          <a:lstStyle/>
-          <a:p>
-            <a:pPr algn="ctr"/>
-            <a:r>
-              <a:rPr lang="en-US" dirty="0">
-                <a:solidFill>
-                  <a:schemeClr val="accent5"/>
-                </a:solidFill>
-              </a:rPr>
-              <a:t>Foreign Key</a:t>
-            </a:r>
-          </a:p>
-        </p:txBody>
-      </p:sp>
-      <p:sp>
-        <p:nvSpPr>
-          <p:cNvPr id="56" name="Right Brace 55">
-            <a:extLst>
-              <a:ext uri="{FF2B5EF4-FFF2-40B4-BE49-F238E27FC236}">
-                <a16:creationId xmlns:a16="http://schemas.microsoft.com/office/drawing/2014/main" id="{B122BDA6-8646-8870-DBA2-9C0923164180}"/>
+          <p:cNvPr id="21" name="Rectangle 20">
+            <a:extLst>
+              <a:ext uri="{FF2B5EF4-FFF2-40B4-BE49-F238E27FC236}">
+                <a16:creationId xmlns:a16="http://schemas.microsoft.com/office/drawing/2014/main" id="{2227594E-1139-3B5B-1CFA-C3509CA71328}"/>
               </a:ext>
             </a:extLst>
           </p:cNvPr>
@@ -8028,242 +7701,9 @@
           <p:nvPr/>
         </p:nvSpPr>
         <p:spPr>
-          <a:xfrm rot="5400000">
-            <a:off x="2082253" y="3620013"/>
-            <a:ext cx="358345" cy="1946532"/>
-          </a:xfrm>
-          <a:prstGeom prst="rightBrace">
-            <a:avLst/>
-          </a:prstGeom>
-        </p:spPr>
-        <p:style>
-          <a:lnRef idx="2">
-            <a:schemeClr val="accent1"/>
-          </a:lnRef>
-          <a:fillRef idx="0">
-            <a:schemeClr val="accent1"/>
-          </a:fillRef>
-          <a:effectRef idx="1">
-            <a:schemeClr val="accent1"/>
-          </a:effectRef>
-          <a:fontRef idx="minor">
-            <a:schemeClr val="tx1"/>
-          </a:fontRef>
-        </p:style>
-        <p:txBody>
-          <a:bodyPr rtlCol="0" anchor="ctr"/>
-          <a:lstStyle/>
-          <a:p>
-            <a:pPr algn="ctr"/>
-            <a:endParaRPr lang="en-US"/>
-          </a:p>
-        </p:txBody>
-      </p:sp>
-      <p:sp>
-        <p:nvSpPr>
-          <p:cNvPr id="57" name="TextBox 56">
-            <a:extLst>
-              <a:ext uri="{FF2B5EF4-FFF2-40B4-BE49-F238E27FC236}">
-                <a16:creationId xmlns:a16="http://schemas.microsoft.com/office/drawing/2014/main" id="{A0E0E682-9317-A3A5-10E7-A8066CA46D22}"/>
-              </a:ext>
-            </a:extLst>
-          </p:cNvPr>
-          <p:cNvSpPr txBox="1"/>
-          <p:nvPr/>
-        </p:nvSpPr>
-        <p:spPr>
-          <a:xfrm>
-            <a:off x="1915789" y="4648544"/>
-            <a:ext cx="3206801" cy="369332"/>
-          </a:xfrm>
-          <a:prstGeom prst="rect">
-            <a:avLst/>
-          </a:prstGeom>
-          <a:noFill/>
-        </p:spPr>
-        <p:txBody>
-          <a:bodyPr wrap="square" rtlCol="0">
-            <a:spAutoFit/>
-          </a:bodyPr>
-          <a:lstStyle/>
-          <a:p>
-            <a:r>
-              <a:rPr lang="en-US" dirty="0"/>
-              <a:t>Composite Primary Key</a:t>
-            </a:r>
-          </a:p>
-        </p:txBody>
-      </p:sp>
-      <p:sp>
-        <p:nvSpPr>
-          <p:cNvPr id="58" name="Right Brace 57">
-            <a:extLst>
-              <a:ext uri="{FF2B5EF4-FFF2-40B4-BE49-F238E27FC236}">
-                <a16:creationId xmlns:a16="http://schemas.microsoft.com/office/drawing/2014/main" id="{C9890756-AD6C-68E2-F4B5-68E41550EC47}"/>
-              </a:ext>
-            </a:extLst>
-          </p:cNvPr>
-          <p:cNvSpPr/>
-          <p:nvPr/>
-        </p:nvSpPr>
-        <p:spPr>
-          <a:xfrm rot="5400000">
-            <a:off x="7330897" y="4809345"/>
-            <a:ext cx="358345" cy="1946532"/>
-          </a:xfrm>
-          <a:prstGeom prst="rightBrace">
-            <a:avLst/>
-          </a:prstGeom>
-        </p:spPr>
-        <p:style>
-          <a:lnRef idx="2">
-            <a:schemeClr val="accent1"/>
-          </a:lnRef>
-          <a:fillRef idx="0">
-            <a:schemeClr val="accent1"/>
-          </a:fillRef>
-          <a:effectRef idx="1">
-            <a:schemeClr val="accent1"/>
-          </a:effectRef>
-          <a:fontRef idx="minor">
-            <a:schemeClr val="tx1"/>
-          </a:fontRef>
-        </p:style>
-        <p:txBody>
-          <a:bodyPr rtlCol="0" anchor="ctr"/>
-          <a:lstStyle/>
-          <a:p>
-            <a:pPr algn="ctr"/>
-            <a:endParaRPr lang="en-US"/>
-          </a:p>
-        </p:txBody>
-      </p:sp>
-      <p:sp>
-        <p:nvSpPr>
-          <p:cNvPr id="59" name="TextBox 58">
-            <a:extLst>
-              <a:ext uri="{FF2B5EF4-FFF2-40B4-BE49-F238E27FC236}">
-                <a16:creationId xmlns:a16="http://schemas.microsoft.com/office/drawing/2014/main" id="{1306BDD4-1934-3B89-BB32-65914A7169EF}"/>
-              </a:ext>
-            </a:extLst>
-          </p:cNvPr>
-          <p:cNvSpPr txBox="1"/>
-          <p:nvPr/>
-        </p:nvSpPr>
-        <p:spPr>
-          <a:xfrm>
-            <a:off x="6783859" y="5789136"/>
-            <a:ext cx="3206801" cy="369332"/>
-          </a:xfrm>
-          <a:prstGeom prst="rect">
-            <a:avLst/>
-          </a:prstGeom>
-          <a:noFill/>
-        </p:spPr>
-        <p:txBody>
-          <a:bodyPr wrap="square" rtlCol="0">
-            <a:spAutoFit/>
-          </a:bodyPr>
-          <a:lstStyle/>
-          <a:p>
-            <a:r>
-              <a:rPr lang="en-US" dirty="0"/>
-              <a:t>Composite Primary Key</a:t>
-            </a:r>
-          </a:p>
-        </p:txBody>
-      </p:sp>
-      <p:sp>
-        <p:nvSpPr>
-          <p:cNvPr id="68" name="TextBox 67">
-            <a:extLst>
-              <a:ext uri="{FF2B5EF4-FFF2-40B4-BE49-F238E27FC236}">
-                <a16:creationId xmlns:a16="http://schemas.microsoft.com/office/drawing/2014/main" id="{785F16E7-9E75-A17F-FA2D-FFCFBEDAEA54}"/>
-              </a:ext>
-            </a:extLst>
-          </p:cNvPr>
-          <p:cNvSpPr txBox="1"/>
-          <p:nvPr/>
-        </p:nvSpPr>
-        <p:spPr>
-          <a:xfrm>
-            <a:off x="4949879" y="6732715"/>
-            <a:ext cx="3206801" cy="369332"/>
-          </a:xfrm>
-          <a:prstGeom prst="rect">
-            <a:avLst/>
-          </a:prstGeom>
-          <a:noFill/>
-        </p:spPr>
-        <p:txBody>
-          <a:bodyPr wrap="square" rtlCol="0">
-            <a:spAutoFit/>
-          </a:bodyPr>
-          <a:lstStyle/>
-          <a:p>
-            <a:r>
-              <a:rPr lang="en-US" dirty="0"/>
-              <a:t>Composite Primary Key</a:t>
-            </a:r>
-          </a:p>
-        </p:txBody>
-      </p:sp>
-      <p:sp>
-        <p:nvSpPr>
-          <p:cNvPr id="69" name="TextBox 68">
-            <a:extLst>
-              <a:ext uri="{FF2B5EF4-FFF2-40B4-BE49-F238E27FC236}">
-                <a16:creationId xmlns:a16="http://schemas.microsoft.com/office/drawing/2014/main" id="{DA17DFD0-9E0A-8E05-49AC-43469205A876}"/>
-              </a:ext>
-            </a:extLst>
-          </p:cNvPr>
-          <p:cNvSpPr txBox="1"/>
-          <p:nvPr/>
-        </p:nvSpPr>
-        <p:spPr>
-          <a:xfrm>
-            <a:off x="2207850" y="5854344"/>
-            <a:ext cx="5368384" cy="369332"/>
-          </a:xfrm>
-          <a:prstGeom prst="rect">
-            <a:avLst/>
-          </a:prstGeom>
-          <a:noFill/>
-        </p:spPr>
-        <p:txBody>
-          <a:bodyPr wrap="square" rtlCol="0">
-            <a:spAutoFit/>
-          </a:bodyPr>
-          <a:lstStyle/>
-          <a:p>
-            <a:pPr algn="ctr"/>
-            <a:r>
-              <a:rPr lang="en-US" dirty="0">
-                <a:solidFill>
-                  <a:schemeClr val="accent5"/>
-                </a:solidFill>
-              </a:rPr>
-              <a:t>Foreign Key</a:t>
-            </a:r>
-          </a:p>
-        </p:txBody>
-      </p:sp>
-      <p:sp>
-        <p:nvSpPr>
-          <p:cNvPr id="70" name="Rectangle 69">
-            <a:extLst>
-              <a:ext uri="{FF2B5EF4-FFF2-40B4-BE49-F238E27FC236}">
-                <a16:creationId xmlns:a16="http://schemas.microsoft.com/office/drawing/2014/main" id="{50A9C9AB-DF32-52D7-D9B8-5B41B078DF06}"/>
-              </a:ext>
-            </a:extLst>
-          </p:cNvPr>
-          <p:cNvSpPr/>
-          <p:nvPr/>
-        </p:nvSpPr>
-        <p:spPr>
-          <a:xfrm>
-            <a:off x="7664901" y="6143360"/>
-            <a:ext cx="1830860" cy="520355"/>
+          <a:xfrm>
+            <a:off x="9771068" y="3878134"/>
+            <a:ext cx="1773086" cy="520355"/>
           </a:xfrm>
           <a:prstGeom prst="rect">
             <a:avLst/>
@@ -8299,252 +7739,13 @@
                   <a:sysClr val="windowText" lastClr="000000"/>
                 </a:solidFill>
               </a:rPr>
-              <a:t>TxnType</a:t>
+              <a:t>PricePaid</a:t>
             </a:r>
             <a:endParaRPr lang="en-US" dirty="0">
               <a:solidFill>
                 <a:sysClr val="windowText" lastClr="000000"/>
               </a:solidFill>
             </a:endParaRPr>
-          </a:p>
-        </p:txBody>
-      </p:sp>
-      <p:sp>
-        <p:nvSpPr>
-          <p:cNvPr id="72" name="Rectangle 71">
-            <a:extLst>
-              <a:ext uri="{FF2B5EF4-FFF2-40B4-BE49-F238E27FC236}">
-                <a16:creationId xmlns:a16="http://schemas.microsoft.com/office/drawing/2014/main" id="{9D682B5A-30AD-FED8-19A1-DF1FD0CB1DA3}"/>
-              </a:ext>
-            </a:extLst>
-          </p:cNvPr>
-          <p:cNvSpPr/>
-          <p:nvPr/>
-        </p:nvSpPr>
-        <p:spPr>
-          <a:xfrm>
-            <a:off x="9497822" y="6150914"/>
-            <a:ext cx="1830860" cy="520355"/>
-          </a:xfrm>
-          <a:prstGeom prst="rect">
-            <a:avLst/>
-          </a:prstGeom>
-          <a:solidFill>
-            <a:schemeClr val="bg1"/>
-          </a:solidFill>
-        </p:spPr>
-        <p:style>
-          <a:lnRef idx="2">
-            <a:schemeClr val="accent1">
-              <a:shade val="15000"/>
-            </a:schemeClr>
-          </a:lnRef>
-          <a:fillRef idx="1">
-            <a:schemeClr val="accent1"/>
-          </a:fillRef>
-          <a:effectRef idx="0">
-            <a:schemeClr val="accent1"/>
-          </a:effectRef>
-          <a:fontRef idx="minor">
-            <a:schemeClr val="lt1"/>
-          </a:fontRef>
-        </p:style>
-        <p:txBody>
-          <a:bodyPr rtlCol="0" anchor="ctr"/>
-          <a:lstStyle/>
-          <a:p>
-            <a:pPr algn="ctr"/>
-            <a:r>
-              <a:rPr lang="en-US" dirty="0" err="1">
-                <a:solidFill>
-                  <a:sysClr val="windowText" lastClr="000000"/>
-                </a:solidFill>
-              </a:rPr>
-              <a:t>TxnDateTime</a:t>
-            </a:r>
-            <a:endParaRPr lang="en-US" dirty="0">
-              <a:solidFill>
-                <a:sysClr val="windowText" lastClr="000000"/>
-              </a:solidFill>
-            </a:endParaRPr>
-          </a:p>
-        </p:txBody>
-      </p:sp>
-      <p:sp>
-        <p:nvSpPr>
-          <p:cNvPr id="73" name="Rectangle 72">
-            <a:extLst>
-              <a:ext uri="{FF2B5EF4-FFF2-40B4-BE49-F238E27FC236}">
-                <a16:creationId xmlns:a16="http://schemas.microsoft.com/office/drawing/2014/main" id="{42BFFA77-00D9-FADB-56FB-61C6742812F7}"/>
-              </a:ext>
-            </a:extLst>
-          </p:cNvPr>
-          <p:cNvSpPr/>
-          <p:nvPr/>
-        </p:nvSpPr>
-        <p:spPr>
-          <a:xfrm>
-            <a:off x="8546756" y="1647057"/>
-            <a:ext cx="1441621" cy="520355"/>
-          </a:xfrm>
-          <a:prstGeom prst="rect">
-            <a:avLst/>
-          </a:prstGeom>
-          <a:solidFill>
-            <a:schemeClr val="bg1"/>
-          </a:solidFill>
-        </p:spPr>
-        <p:style>
-          <a:lnRef idx="2">
-            <a:schemeClr val="accent1">
-              <a:shade val="15000"/>
-            </a:schemeClr>
-          </a:lnRef>
-          <a:fillRef idx="1">
-            <a:schemeClr val="accent1"/>
-          </a:fillRef>
-          <a:effectRef idx="0">
-            <a:schemeClr val="accent1"/>
-          </a:effectRef>
-          <a:fontRef idx="minor">
-            <a:schemeClr val="lt1"/>
-          </a:fontRef>
-        </p:style>
-        <p:txBody>
-          <a:bodyPr rtlCol="0" anchor="ctr"/>
-          <a:lstStyle/>
-          <a:p>
-            <a:pPr algn="ctr"/>
-            <a:r>
-              <a:rPr lang="en-US" dirty="0" err="1">
-                <a:solidFill>
-                  <a:sysClr val="windowText" lastClr="000000"/>
-                </a:solidFill>
-              </a:rPr>
-              <a:t>BidAmount</a:t>
-            </a:r>
-            <a:endParaRPr lang="en-US" dirty="0">
-              <a:solidFill>
-                <a:sysClr val="windowText" lastClr="000000"/>
-              </a:solidFill>
-            </a:endParaRPr>
-          </a:p>
-        </p:txBody>
-      </p:sp>
-      <p:sp>
-        <p:nvSpPr>
-          <p:cNvPr id="74" name="Rectangle 73">
-            <a:extLst>
-              <a:ext uri="{FF2B5EF4-FFF2-40B4-BE49-F238E27FC236}">
-                <a16:creationId xmlns:a16="http://schemas.microsoft.com/office/drawing/2014/main" id="{672E052E-68EA-A418-758B-3873256A4953}"/>
-              </a:ext>
-            </a:extLst>
-          </p:cNvPr>
-          <p:cNvSpPr/>
-          <p:nvPr/>
-        </p:nvSpPr>
-        <p:spPr>
-          <a:xfrm>
-            <a:off x="9989407" y="1640703"/>
-            <a:ext cx="1830860" cy="520355"/>
-          </a:xfrm>
-          <a:prstGeom prst="rect">
-            <a:avLst/>
-          </a:prstGeom>
-          <a:solidFill>
-            <a:schemeClr val="bg1"/>
-          </a:solidFill>
-        </p:spPr>
-        <p:style>
-          <a:lnRef idx="2">
-            <a:schemeClr val="accent1">
-              <a:shade val="15000"/>
-            </a:schemeClr>
-          </a:lnRef>
-          <a:fillRef idx="1">
-            <a:schemeClr val="accent1"/>
-          </a:fillRef>
-          <a:effectRef idx="0">
-            <a:schemeClr val="accent1"/>
-          </a:effectRef>
-          <a:fontRef idx="minor">
-            <a:schemeClr val="lt1"/>
-          </a:fontRef>
-        </p:style>
-        <p:txBody>
-          <a:bodyPr rtlCol="0" anchor="ctr"/>
-          <a:lstStyle/>
-          <a:p>
-            <a:pPr algn="ctr"/>
-            <a:r>
-              <a:rPr lang="en-US" dirty="0" err="1">
-                <a:solidFill>
-                  <a:sysClr val="windowText" lastClr="000000"/>
-                </a:solidFill>
-              </a:rPr>
-              <a:t>ClickURL</a:t>
-            </a:r>
-            <a:endParaRPr lang="en-US" dirty="0">
-              <a:solidFill>
-                <a:sysClr val="windowText" lastClr="000000"/>
-              </a:solidFill>
-            </a:endParaRPr>
-          </a:p>
-        </p:txBody>
-      </p:sp>
-      <p:sp>
-        <p:nvSpPr>
-          <p:cNvPr id="75" name="Rectangle 74">
-            <a:extLst>
-              <a:ext uri="{FF2B5EF4-FFF2-40B4-BE49-F238E27FC236}">
-                <a16:creationId xmlns:a16="http://schemas.microsoft.com/office/drawing/2014/main" id="{7FDA21C2-751C-92EE-5B5F-54145413A477}"/>
-              </a:ext>
-            </a:extLst>
-          </p:cNvPr>
-          <p:cNvSpPr/>
-          <p:nvPr/>
-        </p:nvSpPr>
-        <p:spPr>
-          <a:xfrm>
-            <a:off x="9430734" y="547647"/>
-            <a:ext cx="1830860" cy="520355"/>
-          </a:xfrm>
-          <a:prstGeom prst="rect">
-            <a:avLst/>
-          </a:prstGeom>
-          <a:solidFill>
-            <a:schemeClr val="bg1"/>
-          </a:solidFill>
-        </p:spPr>
-        <p:style>
-          <a:lnRef idx="2">
-            <a:schemeClr val="accent1">
-              <a:shade val="15000"/>
-            </a:schemeClr>
-          </a:lnRef>
-          <a:fillRef idx="1">
-            <a:schemeClr val="accent1"/>
-          </a:fillRef>
-          <a:effectRef idx="0">
-            <a:schemeClr val="accent1"/>
-          </a:effectRef>
-          <a:fontRef idx="minor">
-            <a:schemeClr val="lt1"/>
-          </a:fontRef>
-        </p:style>
-        <p:txBody>
-          <a:bodyPr rtlCol="0" anchor="ctr"/>
-          <a:lstStyle/>
-          <a:p>
-            <a:pPr algn="ctr"/>
-            <a:r>
-              <a:rPr lang="en-US" dirty="0">
-                <a:solidFill>
-                  <a:sysClr val="windowText" lastClr="000000"/>
-                </a:solidFill>
-              </a:rPr>
-              <a:t>Budget</a:t>
-            </a:r>
           </a:p>
         </p:txBody>
       </p:sp>

</xml_diff>